<commit_message>
Switch presentation to light theme with SRAM red used sparingly
Off-white background (#F5F5F3), white cards, black text, gray
secondary text. SRAM red (#E51937) appears only as thin accent
lines and left-edge bars on callout boxes. Muted red (#C43B4F)
used only for the Trustpilot and complaint metrics on slide 4.
</commit_message>
<xml_diff>
--- a/presentation/SRAM_AI_Adoption_Playbook.pptx
+++ b/presentation/SRAM_AI_Adoption_Playbook.pptx
@@ -3091,7 +3091,7 @@
     <p:bg>
       <p:bgPr>
         <a:solidFill>
-          <a:srgbClr val="1C1C1E"/>
+          <a:srgbClr val="F5F5F3"/>
         </a:solidFill>
         <a:effectLst/>
       </p:bgPr>
@@ -3112,7 +3112,7 @@
         <p:spPr>
           <a:xfrm>
             <a:off x="1371600" y="2377440"/>
-            <a:ext cx="1371600" cy="38100"/>
+            <a:ext cx="1097280" cy="38100"/>
           </a:xfrm>
           <a:prstGeom prst="rect">
             <a:avLst/>
@@ -3174,7 +3174,7 @@
               </a:spcAft>
               <a:defRPr sz="4400" b="1">
                 <a:solidFill>
-                  <a:srgbClr val="FFFFFF"/>
+                  <a:srgbClr val="1C1C1E"/>
                 </a:solidFill>
                 <a:latin typeface="Calibri"/>
               </a:defRPr>
@@ -3190,7 +3190,7 @@
               </a:spcAft>
               <a:defRPr sz="2600" b="0">
                 <a:solidFill>
-                  <a:srgbClr val="E51937"/>
+                  <a:srgbClr val="767676"/>
                 </a:solidFill>
                 <a:latin typeface="Calibri"/>
               </a:defRPr>
@@ -3219,7 +3219,7 @@
               </a:spcAft>
               <a:defRPr sz="1400" b="0">
                 <a:solidFill>
-                  <a:srgbClr val="D9DBD8"/>
+                  <a:srgbClr val="3A3A3C"/>
                 </a:solidFill>
                 <a:latin typeface="Calibri"/>
               </a:defRPr>
@@ -3296,7 +3296,7 @@
     <p:bg>
       <p:bgPr>
         <a:solidFill>
-          <a:srgbClr val="1C1C1E"/>
+          <a:srgbClr val="F5F5F3"/>
         </a:solidFill>
         <a:effectLst/>
       </p:bgPr>
@@ -3333,7 +3333,7 @@
             <a:pPr algn="l">
               <a:defRPr sz="1100" b="1">
                 <a:solidFill>
-                  <a:srgbClr val="E51937"/>
+                  <a:srgbClr val="767676"/>
                 </a:solidFill>
                 <a:latin typeface="Calibri"/>
               </a:defRPr>
@@ -3369,7 +3369,7 @@
             <a:pPr algn="l">
               <a:defRPr sz="3200" b="1">
                 <a:solidFill>
-                  <a:srgbClr val="FFFFFF"/>
+                  <a:srgbClr val="1C1C1E"/>
                 </a:solidFill>
                 <a:latin typeface="Calibri"/>
               </a:defRPr>
@@ -3389,7 +3389,7 @@
         <p:spPr>
           <a:xfrm>
             <a:off x="731520" y="1051560"/>
-            <a:ext cx="914400" cy="25400"/>
+            <a:ext cx="731520" cy="38100"/>
           </a:xfrm>
           <a:prstGeom prst="rect">
             <a:avLst/>
@@ -3448,7 +3448,7 @@
             <a:pPr algn="l">
               <a:defRPr sz="1400" b="0">
                 <a:solidFill>
-                  <a:srgbClr val="D9DBD8"/>
+                  <a:srgbClr val="3A3A3C"/>
                 </a:solidFill>
                 <a:latin typeface="Calibri"/>
               </a:defRPr>
@@ -3476,11 +3476,11 @@
             </a:avLst>
           </a:prstGeom>
           <a:solidFill>
-            <a:srgbClr val="2A2A2C"/>
+            <a:srgbClr val="FFFFFF"/>
           </a:solidFill>
           <a:ln w="12700">
             <a:solidFill>
-              <a:srgbClr val="3A3A3C"/>
+              <a:srgbClr val="E0E0DE"/>
             </a:solidFill>
           </a:ln>
         </p:spPr>
@@ -3567,7 +3567,7 @@
             <a:pPr algn="l">
               <a:defRPr sz="2600" b="1">
                 <a:solidFill>
-                  <a:srgbClr val="E51937"/>
+                  <a:srgbClr val="1C1C1E"/>
                 </a:solidFill>
                 <a:latin typeface="Calibri"/>
               </a:defRPr>
@@ -3631,11 +3631,11 @@
             </a:avLst>
           </a:prstGeom>
           <a:solidFill>
-            <a:srgbClr val="2A2A2C"/>
+            <a:srgbClr val="FFFFFF"/>
           </a:solidFill>
           <a:ln w="12700">
             <a:solidFill>
-              <a:srgbClr val="3A3A3C"/>
+              <a:srgbClr val="E0E0DE"/>
             </a:solidFill>
           </a:ln>
         </p:spPr>
@@ -3722,7 +3722,7 @@
             <a:pPr algn="l">
               <a:defRPr sz="2600" b="1">
                 <a:solidFill>
-                  <a:srgbClr val="E51937"/>
+                  <a:srgbClr val="1C1C1E"/>
                 </a:solidFill>
                 <a:latin typeface="Calibri"/>
               </a:defRPr>
@@ -3786,11 +3786,11 @@
             </a:avLst>
           </a:prstGeom>
           <a:solidFill>
-            <a:srgbClr val="2A2A2C"/>
+            <a:srgbClr val="FFFFFF"/>
           </a:solidFill>
           <a:ln w="12700">
             <a:solidFill>
-              <a:srgbClr val="3A3A3C"/>
+              <a:srgbClr val="E0E0DE"/>
             </a:solidFill>
           </a:ln>
         </p:spPr>
@@ -3877,7 +3877,7 @@
             <a:pPr algn="l">
               <a:defRPr sz="2600" b="1">
                 <a:solidFill>
-                  <a:srgbClr val="E51937"/>
+                  <a:srgbClr val="1C1C1E"/>
                 </a:solidFill>
                 <a:latin typeface="Calibri"/>
               </a:defRPr>
@@ -3941,11 +3941,11 @@
             </a:avLst>
           </a:prstGeom>
           <a:solidFill>
-            <a:srgbClr val="2A2A2C"/>
+            <a:srgbClr val="FFFFFF"/>
           </a:solidFill>
           <a:ln w="12700">
             <a:solidFill>
-              <a:srgbClr val="3A3A3C"/>
+              <a:srgbClr val="E0E0DE"/>
             </a:solidFill>
           </a:ln>
         </p:spPr>
@@ -4032,7 +4032,7 @@
             <a:pPr algn="l">
               <a:defRPr sz="2600" b="1">
                 <a:solidFill>
-                  <a:srgbClr val="E51937"/>
+                  <a:srgbClr val="1C1C1E"/>
                 </a:solidFill>
                 <a:latin typeface="Calibri"/>
               </a:defRPr>
@@ -4104,7 +4104,7 @@
             <a:pPr algn="l">
               <a:defRPr sz="1600" b="1">
                 <a:solidFill>
-                  <a:srgbClr val="FFFFFF"/>
+                  <a:srgbClr val="1C1C1E"/>
                 </a:solidFill>
                 <a:latin typeface="Calibri"/>
               </a:defRPr>
@@ -4140,7 +4140,7 @@
             <a:pPr algn="l">
               <a:defRPr sz="1200" b="1">
                 <a:solidFill>
-                  <a:srgbClr val="FFFFFF"/>
+                  <a:srgbClr val="1C1C1E"/>
                 </a:solidFill>
                 <a:latin typeface="Calibri"/>
               </a:defRPr>
@@ -4212,7 +4212,7 @@
             <a:pPr algn="l">
               <a:defRPr sz="1200" b="1">
                 <a:solidFill>
-                  <a:srgbClr val="FFFFFF"/>
+                  <a:srgbClr val="1C1C1E"/>
                 </a:solidFill>
                 <a:latin typeface="Calibri"/>
               </a:defRPr>
@@ -4284,7 +4284,7 @@
             <a:pPr algn="l">
               <a:defRPr sz="1200" b="1">
                 <a:solidFill>
-                  <a:srgbClr val="FFFFFF"/>
+                  <a:srgbClr val="1C1C1E"/>
                 </a:solidFill>
                 <a:latin typeface="Calibri"/>
               </a:defRPr>
@@ -4356,7 +4356,7 @@
             <a:pPr algn="l">
               <a:defRPr sz="1200" b="1">
                 <a:solidFill>
-                  <a:srgbClr val="FFFFFF"/>
+                  <a:srgbClr val="1C1C1E"/>
                 </a:solidFill>
                 <a:latin typeface="Calibri"/>
               </a:defRPr>
@@ -4428,7 +4428,7 @@
             <a:pPr algn="l">
               <a:defRPr sz="1200" b="1">
                 <a:solidFill>
-                  <a:srgbClr val="FFFFFF"/>
+                  <a:srgbClr val="1C1C1E"/>
                 </a:solidFill>
                 <a:latin typeface="Calibri"/>
               </a:defRPr>
@@ -4500,7 +4500,7 @@
             <a:pPr algn="l">
               <a:defRPr sz="1200" b="1">
                 <a:solidFill>
-                  <a:srgbClr val="FFFFFF"/>
+                  <a:srgbClr val="1C1C1E"/>
                 </a:solidFill>
                 <a:latin typeface="Calibri"/>
               </a:defRPr>
@@ -4564,11 +4564,11 @@
             </a:avLst>
           </a:prstGeom>
           <a:solidFill>
-            <a:srgbClr val="2A2A2C"/>
+            <a:srgbClr val="FFFFFF"/>
           </a:solidFill>
           <a:ln w="12700">
             <a:solidFill>
-              <a:srgbClr val="3A3A3C"/>
+              <a:srgbClr val="E0E0DE"/>
             </a:solidFill>
           </a:ln>
         </p:spPr>
@@ -4619,7 +4619,7 @@
             <a:pPr algn="l">
               <a:defRPr sz="1400" b="1">
                 <a:solidFill>
-                  <a:srgbClr val="E3475E"/>
+                  <a:srgbClr val="1C1C1E"/>
                 </a:solidFill>
                 <a:latin typeface="Calibri"/>
               </a:defRPr>
@@ -4658,7 +4658,7 @@
               </a:spcAft>
               <a:defRPr sz="1100" b="0">
                 <a:solidFill>
-                  <a:srgbClr val="D9DBD8"/>
+                  <a:srgbClr val="3A3A3C"/>
                 </a:solidFill>
                 <a:latin typeface="Calibri"/>
               </a:defRPr>
@@ -4674,7 +4674,7 @@
               </a:spcAft>
               <a:defRPr sz="1100" b="0">
                 <a:solidFill>
-                  <a:srgbClr val="D9DBD8"/>
+                  <a:srgbClr val="3A3A3C"/>
                 </a:solidFill>
                 <a:latin typeface="Calibri"/>
               </a:defRPr>
@@ -4690,7 +4690,7 @@
               </a:spcAft>
               <a:defRPr sz="1100" b="0">
                 <a:solidFill>
-                  <a:srgbClr val="D9DBD8"/>
+                  <a:srgbClr val="3A3A3C"/>
                 </a:solidFill>
                 <a:latin typeface="Calibri"/>
               </a:defRPr>
@@ -4715,7 +4715,7 @@
     <p:bg>
       <p:bgPr>
         <a:solidFill>
-          <a:srgbClr val="1C1C1E"/>
+          <a:srgbClr val="F5F5F3"/>
         </a:solidFill>
         <a:effectLst/>
       </p:bgPr>
@@ -4752,7 +4752,7 @@
             <a:pPr algn="l">
               <a:defRPr sz="1100" b="1">
                 <a:solidFill>
-                  <a:srgbClr val="E51937"/>
+                  <a:srgbClr val="767676"/>
                 </a:solidFill>
                 <a:latin typeface="Calibri"/>
               </a:defRPr>
@@ -4788,7 +4788,7 @@
             <a:pPr algn="l">
               <a:defRPr sz="3200" b="1">
                 <a:solidFill>
-                  <a:srgbClr val="FFFFFF"/>
+                  <a:srgbClr val="1C1C1E"/>
                 </a:solidFill>
                 <a:latin typeface="Calibri"/>
               </a:defRPr>
@@ -4808,7 +4808,7 @@
         <p:spPr>
           <a:xfrm>
             <a:off x="731520" y="1051560"/>
-            <a:ext cx="914400" cy="25400"/>
+            <a:ext cx="731520" cy="38100"/>
           </a:xfrm>
           <a:prstGeom prst="rect">
             <a:avLst/>
@@ -4867,7 +4867,7 @@
             <a:pPr algn="l">
               <a:defRPr sz="1400" b="0">
                 <a:solidFill>
-                  <a:srgbClr val="D9DBD8"/>
+                  <a:srgbClr val="3A3A3C"/>
                 </a:solidFill>
                 <a:latin typeface="Calibri"/>
               </a:defRPr>
@@ -4895,11 +4895,11 @@
             </a:avLst>
           </a:prstGeom>
           <a:solidFill>
-            <a:srgbClr val="2A2A2C"/>
+            <a:srgbClr val="FFFFFF"/>
           </a:solidFill>
           <a:ln w="12700">
             <a:solidFill>
-              <a:srgbClr val="3A3A3C"/>
+              <a:srgbClr val="E0E0DE"/>
             </a:solidFill>
           </a:ln>
         </p:spPr>
@@ -4950,7 +4950,7 @@
             <a:pPr algn="l">
               <a:defRPr sz="800" b="1">
                 <a:solidFill>
-                  <a:srgbClr val="E51937"/>
+                  <a:srgbClr val="767676"/>
                 </a:solidFill>
                 <a:latin typeface="Calibri"/>
               </a:defRPr>
@@ -4986,7 +4986,7 @@
             <a:pPr algn="l">
               <a:defRPr sz="1300" b="1">
                 <a:solidFill>
-                  <a:srgbClr val="FFFFFF"/>
+                  <a:srgbClr val="1C1C1E"/>
                 </a:solidFill>
                 <a:latin typeface="Calibri"/>
               </a:defRPr>
@@ -5050,11 +5050,11 @@
             </a:avLst>
           </a:prstGeom>
           <a:solidFill>
-            <a:srgbClr val="2A2A2C"/>
+            <a:srgbClr val="FFFFFF"/>
           </a:solidFill>
           <a:ln w="12700">
             <a:solidFill>
-              <a:srgbClr val="3A3A3C"/>
+              <a:srgbClr val="E0E0DE"/>
             </a:solidFill>
           </a:ln>
         </p:spPr>
@@ -5105,7 +5105,7 @@
             <a:pPr algn="l">
               <a:defRPr sz="800" b="1">
                 <a:solidFill>
-                  <a:srgbClr val="E51937"/>
+                  <a:srgbClr val="767676"/>
                 </a:solidFill>
                 <a:latin typeface="Calibri"/>
               </a:defRPr>
@@ -5141,7 +5141,7 @@
             <a:pPr algn="l">
               <a:defRPr sz="1300" b="1">
                 <a:solidFill>
-                  <a:srgbClr val="FFFFFF"/>
+                  <a:srgbClr val="1C1C1E"/>
                 </a:solidFill>
                 <a:latin typeface="Calibri"/>
               </a:defRPr>
@@ -5205,11 +5205,11 @@
             </a:avLst>
           </a:prstGeom>
           <a:solidFill>
-            <a:srgbClr val="2A2A2C"/>
+            <a:srgbClr val="FFFFFF"/>
           </a:solidFill>
           <a:ln w="12700">
             <a:solidFill>
-              <a:srgbClr val="3A3A3C"/>
+              <a:srgbClr val="E0E0DE"/>
             </a:solidFill>
           </a:ln>
         </p:spPr>
@@ -5260,7 +5260,7 @@
             <a:pPr algn="l">
               <a:defRPr sz="800" b="1">
                 <a:solidFill>
-                  <a:srgbClr val="E51937"/>
+                  <a:srgbClr val="767676"/>
                 </a:solidFill>
                 <a:latin typeface="Calibri"/>
               </a:defRPr>
@@ -5296,7 +5296,7 @@
             <a:pPr algn="l">
               <a:defRPr sz="1300" b="1">
                 <a:solidFill>
-                  <a:srgbClr val="FFFFFF"/>
+                  <a:srgbClr val="1C1C1E"/>
                 </a:solidFill>
                 <a:latin typeface="Calibri"/>
               </a:defRPr>
@@ -5360,11 +5360,11 @@
             </a:avLst>
           </a:prstGeom>
           <a:solidFill>
-            <a:srgbClr val="2A2A2C"/>
+            <a:srgbClr val="FFFFFF"/>
           </a:solidFill>
           <a:ln w="12700">
             <a:solidFill>
-              <a:srgbClr val="3A3A3C"/>
+              <a:srgbClr val="E0E0DE"/>
             </a:solidFill>
           </a:ln>
         </p:spPr>
@@ -5415,7 +5415,7 @@
             <a:pPr algn="l">
               <a:defRPr sz="800" b="1">
                 <a:solidFill>
-                  <a:srgbClr val="E51937"/>
+                  <a:srgbClr val="767676"/>
                 </a:solidFill>
                 <a:latin typeface="Calibri"/>
               </a:defRPr>
@@ -5451,7 +5451,7 @@
             <a:pPr algn="l">
               <a:defRPr sz="1300" b="1">
                 <a:solidFill>
-                  <a:srgbClr val="FFFFFF"/>
+                  <a:srgbClr val="1C1C1E"/>
                 </a:solidFill>
                 <a:latin typeface="Calibri"/>
               </a:defRPr>
@@ -5515,11 +5515,11 @@
             </a:avLst>
           </a:prstGeom>
           <a:solidFill>
-            <a:srgbClr val="2A2A2C"/>
+            <a:srgbClr val="FFFFFF"/>
           </a:solidFill>
           <a:ln w="12700">
             <a:solidFill>
-              <a:srgbClr val="3A3A3C"/>
+              <a:srgbClr val="E0E0DE"/>
             </a:solidFill>
           </a:ln>
         </p:spPr>
@@ -5570,7 +5570,7 @@
             <a:pPr algn="l">
               <a:defRPr sz="800" b="1">
                 <a:solidFill>
-                  <a:srgbClr val="E51937"/>
+                  <a:srgbClr val="767676"/>
                 </a:solidFill>
                 <a:latin typeface="Calibri"/>
               </a:defRPr>
@@ -5606,7 +5606,7 @@
             <a:pPr algn="l">
               <a:defRPr sz="1300" b="1">
                 <a:solidFill>
-                  <a:srgbClr val="FFFFFF"/>
+                  <a:srgbClr val="1C1C1E"/>
                 </a:solidFill>
                 <a:latin typeface="Calibri"/>
               </a:defRPr>
@@ -5670,11 +5670,11 @@
             </a:avLst>
           </a:prstGeom>
           <a:solidFill>
-            <a:srgbClr val="2A2A2C"/>
+            <a:srgbClr val="FFFFFF"/>
           </a:solidFill>
           <a:ln w="12700">
             <a:solidFill>
-              <a:srgbClr val="3A3A3C"/>
+              <a:srgbClr val="E0E0DE"/>
             </a:solidFill>
           </a:ln>
         </p:spPr>
@@ -5725,7 +5725,7 @@
             <a:pPr algn="l">
               <a:defRPr sz="800" b="1">
                 <a:solidFill>
-                  <a:srgbClr val="E51937"/>
+                  <a:srgbClr val="767676"/>
                 </a:solidFill>
                 <a:latin typeface="Calibri"/>
               </a:defRPr>
@@ -5761,7 +5761,7 @@
             <a:pPr algn="l">
               <a:defRPr sz="1300" b="1">
                 <a:solidFill>
-                  <a:srgbClr val="FFFFFF"/>
+                  <a:srgbClr val="1C1C1E"/>
                 </a:solidFill>
                 <a:latin typeface="Calibri"/>
               </a:defRPr>
@@ -5825,11 +5825,11 @@
             </a:avLst>
           </a:prstGeom>
           <a:solidFill>
-            <a:srgbClr val="2A2A2C"/>
+            <a:srgbClr val="FFFFFF"/>
           </a:solidFill>
           <a:ln w="12700">
             <a:solidFill>
-              <a:srgbClr val="3A3A3C"/>
+              <a:srgbClr val="E0E0DE"/>
             </a:solidFill>
           </a:ln>
         </p:spPr>
@@ -5880,7 +5880,7 @@
             <a:pPr algn="l">
               <a:defRPr sz="800" b="1">
                 <a:solidFill>
-                  <a:srgbClr val="E51937"/>
+                  <a:srgbClr val="767676"/>
                 </a:solidFill>
                 <a:latin typeface="Calibri"/>
               </a:defRPr>
@@ -5916,7 +5916,7 @@
             <a:pPr algn="l">
               <a:defRPr sz="1300" b="1">
                 <a:solidFill>
-                  <a:srgbClr val="FFFFFF"/>
+                  <a:srgbClr val="1C1C1E"/>
                 </a:solidFill>
                 <a:latin typeface="Calibri"/>
               </a:defRPr>
@@ -5980,11 +5980,11 @@
             </a:avLst>
           </a:prstGeom>
           <a:solidFill>
-            <a:srgbClr val="2A2A2C"/>
+            <a:srgbClr val="FFFFFF"/>
           </a:solidFill>
           <a:ln w="12700">
             <a:solidFill>
-              <a:srgbClr val="3A3A3C"/>
+              <a:srgbClr val="E0E0DE"/>
             </a:solidFill>
           </a:ln>
         </p:spPr>
@@ -6035,7 +6035,7 @@
             <a:pPr algn="l">
               <a:defRPr sz="800" b="1">
                 <a:solidFill>
-                  <a:srgbClr val="E51937"/>
+                  <a:srgbClr val="767676"/>
                 </a:solidFill>
                 <a:latin typeface="Calibri"/>
               </a:defRPr>
@@ -6071,7 +6071,7 @@
             <a:pPr algn="l">
               <a:defRPr sz="1300" b="1">
                 <a:solidFill>
-                  <a:srgbClr val="FFFFFF"/>
+                  <a:srgbClr val="1C1C1E"/>
                 </a:solidFill>
                 <a:latin typeface="Calibri"/>
               </a:defRPr>
@@ -6135,11 +6135,11 @@
             </a:avLst>
           </a:prstGeom>
           <a:solidFill>
-            <a:srgbClr val="2A2A2C"/>
+            <a:srgbClr val="FFFFFF"/>
           </a:solidFill>
           <a:ln w="12700">
             <a:solidFill>
-              <a:srgbClr val="3A3A3C"/>
+              <a:srgbClr val="E0E0DE"/>
             </a:solidFill>
           </a:ln>
         </p:spPr>
@@ -6190,7 +6190,7 @@
             <a:pPr algn="l">
               <a:defRPr sz="800" b="1">
                 <a:solidFill>
-                  <a:srgbClr val="E51937"/>
+                  <a:srgbClr val="767676"/>
                 </a:solidFill>
                 <a:latin typeface="Calibri"/>
               </a:defRPr>
@@ -6226,7 +6226,7 @@
             <a:pPr algn="l">
               <a:defRPr sz="1300" b="1">
                 <a:solidFill>
-                  <a:srgbClr val="FFFFFF"/>
+                  <a:srgbClr val="1C1C1E"/>
                 </a:solidFill>
                 <a:latin typeface="Calibri"/>
               </a:defRPr>
@@ -6290,11 +6290,11 @@
             </a:avLst>
           </a:prstGeom>
           <a:solidFill>
-            <a:srgbClr val="2A2A2C"/>
+            <a:srgbClr val="FFFFFF"/>
           </a:solidFill>
           <a:ln w="12700">
             <a:solidFill>
-              <a:srgbClr val="3A3A3C"/>
+              <a:srgbClr val="E0E0DE"/>
             </a:solidFill>
           </a:ln>
         </p:spPr>
@@ -6345,7 +6345,7 @@
             <a:pPr algn="l">
               <a:defRPr sz="800" b="1">
                 <a:solidFill>
-                  <a:srgbClr val="E51937"/>
+                  <a:srgbClr val="767676"/>
                 </a:solidFill>
                 <a:latin typeface="Calibri"/>
               </a:defRPr>
@@ -6381,7 +6381,7 @@
             <a:pPr algn="l">
               <a:defRPr sz="1300" b="1">
                 <a:solidFill>
-                  <a:srgbClr val="FFFFFF"/>
+                  <a:srgbClr val="1C1C1E"/>
                 </a:solidFill>
                 <a:latin typeface="Calibri"/>
               </a:defRPr>
@@ -6445,11 +6445,11 @@
             </a:avLst>
           </a:prstGeom>
           <a:solidFill>
-            <a:srgbClr val="2A2A2C"/>
+            <a:srgbClr val="FFFFFF"/>
           </a:solidFill>
           <a:ln w="12700">
             <a:solidFill>
-              <a:srgbClr val="3A3A3C"/>
+              <a:srgbClr val="E0E0DE"/>
             </a:solidFill>
           </a:ln>
         </p:spPr>
@@ -6500,7 +6500,7 @@
             <a:pPr algn="l">
               <a:defRPr sz="800" b="1">
                 <a:solidFill>
-                  <a:srgbClr val="E51937"/>
+                  <a:srgbClr val="767676"/>
                 </a:solidFill>
                 <a:latin typeface="Calibri"/>
               </a:defRPr>
@@ -6536,7 +6536,7 @@
             <a:pPr algn="l">
               <a:defRPr sz="1300" b="1">
                 <a:solidFill>
-                  <a:srgbClr val="FFFFFF"/>
+                  <a:srgbClr val="1C1C1E"/>
                 </a:solidFill>
                 <a:latin typeface="Calibri"/>
               </a:defRPr>
@@ -6600,11 +6600,11 @@
             </a:avLst>
           </a:prstGeom>
           <a:solidFill>
-            <a:srgbClr val="2A2A2C"/>
+            <a:srgbClr val="FFFFFF"/>
           </a:solidFill>
           <a:ln w="12700">
             <a:solidFill>
-              <a:srgbClr val="3A3A3C"/>
+              <a:srgbClr val="E0E0DE"/>
             </a:solidFill>
           </a:ln>
         </p:spPr>
@@ -6655,7 +6655,7 @@
             <a:pPr algn="l">
               <a:defRPr sz="800" b="1">
                 <a:solidFill>
-                  <a:srgbClr val="E51937"/>
+                  <a:srgbClr val="767676"/>
                 </a:solidFill>
                 <a:latin typeface="Calibri"/>
               </a:defRPr>
@@ -6691,7 +6691,7 @@
             <a:pPr algn="l">
               <a:defRPr sz="1300" b="1">
                 <a:solidFill>
-                  <a:srgbClr val="FFFFFF"/>
+                  <a:srgbClr val="1C1C1E"/>
                 </a:solidFill>
                 <a:latin typeface="Calibri"/>
               </a:defRPr>
@@ -6755,11 +6755,11 @@
             </a:avLst>
           </a:prstGeom>
           <a:solidFill>
-            <a:srgbClr val="2A2A2C"/>
+            <a:srgbClr val="FFFFFF"/>
           </a:solidFill>
           <a:ln w="12700">
             <a:solidFill>
-              <a:srgbClr val="E51937"/>
+              <a:srgbClr val="E0E0DE"/>
             </a:solidFill>
           </a:ln>
         </p:spPr>
@@ -6787,7 +6787,50 @@
       </p:sp>
       <p:sp>
         <p:nvSpPr>
-          <p:cNvPr id="55" name="TextBox 54"/>
+          <p:cNvPr id="55" name="Rectangle 54"/>
+          <p:cNvSpPr/>
+          <p:nvPr/>
+        </p:nvSpPr>
+        <p:spPr>
+          <a:xfrm>
+            <a:off x="731520" y="6400800"/>
+            <a:ext cx="50800" cy="320040"/>
+          </a:xfrm>
+          <a:prstGeom prst="rect">
+            <a:avLst/>
+          </a:prstGeom>
+          <a:solidFill>
+            <a:srgbClr val="E51937"/>
+          </a:solidFill>
+          <a:ln>
+            <a:noFill/>
+          </a:ln>
+        </p:spPr>
+        <p:style>
+          <a:lnRef idx="1">
+            <a:schemeClr val="accent1"/>
+          </a:lnRef>
+          <a:fillRef idx="3">
+            <a:schemeClr val="accent1"/>
+          </a:fillRef>
+          <a:effectRef idx="2">
+            <a:schemeClr val="accent1"/>
+          </a:effectRef>
+          <a:fontRef idx="minor">
+            <a:schemeClr val="lt1"/>
+          </a:fontRef>
+        </p:style>
+        <p:txBody>
+          <a:bodyPr rtlCol="0" anchor="ctr"/>
+          <a:lstStyle/>
+          <a:p>
+            <a:pPr algn="ctr"/>
+          </a:p>
+        </p:txBody>
+      </p:sp>
+      <p:sp>
+        <p:nvSpPr>
+          <p:cNvPr id="56" name="TextBox 55"/>
           <p:cNvSpPr txBox="1"/>
           <p:nvPr/>
         </p:nvSpPr>
@@ -6810,13 +6853,13 @@
             <a:pPr algn="ctr">
               <a:defRPr sz="1200" b="1">
                 <a:solidFill>
-                  <a:srgbClr val="E51937"/>
-                </a:solidFill>
-                <a:latin typeface="Calibri"/>
-              </a:defRPr>
-            </a:pPr>
-            <a:r>
-              <a:t>We will focus on one area with the highest uplift and fastest proof: Customer and Dealer Support</a:t>
+                  <a:srgbClr val="1C1C1E"/>
+                </a:solidFill>
+                <a:latin typeface="Calibri"/>
+              </a:defRPr>
+            </a:pPr>
+            <a:r>
+              <a:t>We focus on the area with the highest uplift and fastest proof: Customer and Dealer Support</a:t>
             </a:r>
           </a:p>
         </p:txBody>
@@ -6835,7 +6878,7 @@
     <p:bg>
       <p:bgPr>
         <a:solidFill>
-          <a:srgbClr val="1C1C1E"/>
+          <a:srgbClr val="F5F5F3"/>
         </a:solidFill>
         <a:effectLst/>
       </p:bgPr>
@@ -6872,7 +6915,7 @@
             <a:pPr algn="l">
               <a:defRPr sz="1100" b="1">
                 <a:solidFill>
-                  <a:srgbClr val="E51937"/>
+                  <a:srgbClr val="767676"/>
                 </a:solidFill>
                 <a:latin typeface="Calibri"/>
               </a:defRPr>
@@ -6908,7 +6951,7 @@
             <a:pPr algn="l">
               <a:defRPr sz="3200" b="1">
                 <a:solidFill>
-                  <a:srgbClr val="FFFFFF"/>
+                  <a:srgbClr val="1C1C1E"/>
                 </a:solidFill>
                 <a:latin typeface="Calibri"/>
               </a:defRPr>
@@ -6928,7 +6971,7 @@
         <p:spPr>
           <a:xfrm>
             <a:off x="731520" y="1051560"/>
-            <a:ext cx="914400" cy="25400"/>
+            <a:ext cx="731520" cy="38100"/>
           </a:xfrm>
           <a:prstGeom prst="rect">
             <a:avLst/>
@@ -6987,7 +7030,7 @@
             <a:pPr algn="l">
               <a:defRPr sz="1400" b="0">
                 <a:solidFill>
-                  <a:srgbClr val="D9DBD8"/>
+                  <a:srgbClr val="3A3A3C"/>
                 </a:solidFill>
                 <a:latin typeface="Calibri"/>
               </a:defRPr>
@@ -7015,11 +7058,11 @@
             </a:avLst>
           </a:prstGeom>
           <a:solidFill>
-            <a:srgbClr val="2A2A2C"/>
+            <a:srgbClr val="FFFFFF"/>
           </a:solidFill>
           <a:ln w="12700">
             <a:solidFill>
-              <a:srgbClr val="3A3A3C"/>
+              <a:srgbClr val="E0E0DE"/>
             </a:solidFill>
           </a:ln>
         </p:spPr>
@@ -7106,7 +7149,7 @@
             <a:pPr algn="l">
               <a:defRPr sz="2600" b="1">
                 <a:solidFill>
-                  <a:srgbClr val="E3475E"/>
+                  <a:srgbClr val="C43B4F"/>
                 </a:solidFill>
                 <a:latin typeface="Calibri"/>
               </a:defRPr>
@@ -7170,11 +7213,11 @@
             </a:avLst>
           </a:prstGeom>
           <a:solidFill>
-            <a:srgbClr val="2A2A2C"/>
+            <a:srgbClr val="FFFFFF"/>
           </a:solidFill>
           <a:ln w="12700">
             <a:solidFill>
-              <a:srgbClr val="3A3A3C"/>
+              <a:srgbClr val="E0E0DE"/>
             </a:solidFill>
           </a:ln>
         </p:spPr>
@@ -7261,7 +7304,7 @@
             <a:pPr algn="l">
               <a:defRPr sz="2600" b="1">
                 <a:solidFill>
-                  <a:srgbClr val="FFFFFF"/>
+                  <a:srgbClr val="1C1C1E"/>
                 </a:solidFill>
                 <a:latin typeface="Calibri"/>
               </a:defRPr>
@@ -7325,11 +7368,11 @@
             </a:avLst>
           </a:prstGeom>
           <a:solidFill>
-            <a:srgbClr val="2A2A2C"/>
+            <a:srgbClr val="FFFFFF"/>
           </a:solidFill>
           <a:ln w="12700">
             <a:solidFill>
-              <a:srgbClr val="3A3A3C"/>
+              <a:srgbClr val="E0E0DE"/>
             </a:solidFill>
           </a:ln>
         </p:spPr>
@@ -7416,7 +7459,7 @@
             <a:pPr algn="l">
               <a:defRPr sz="2600" b="1">
                 <a:solidFill>
-                  <a:srgbClr val="E3475E"/>
+                  <a:srgbClr val="C43B4F"/>
                 </a:solidFill>
                 <a:latin typeface="Calibri"/>
               </a:defRPr>
@@ -7480,11 +7523,11 @@
             </a:avLst>
           </a:prstGeom>
           <a:solidFill>
-            <a:srgbClr val="2A2A2C"/>
+            <a:srgbClr val="FFFFFF"/>
           </a:solidFill>
           <a:ln w="12700">
             <a:solidFill>
-              <a:srgbClr val="3A3A3C"/>
+              <a:srgbClr val="E0E0DE"/>
             </a:solidFill>
           </a:ln>
         </p:spPr>
@@ -7535,7 +7578,7 @@
             <a:pPr algn="l">
               <a:defRPr sz="1400" b="1">
                 <a:solidFill>
-                  <a:srgbClr val="E3475E"/>
+                  <a:srgbClr val="1C1C1E"/>
                 </a:solidFill>
                 <a:latin typeface="Calibri"/>
               </a:defRPr>
@@ -7574,7 +7617,7 @@
               </a:spcAft>
               <a:defRPr sz="1100" b="0">
                 <a:solidFill>
-                  <a:srgbClr val="D9DBD8"/>
+                  <a:srgbClr val="3A3A3C"/>
                 </a:solidFill>
                 <a:latin typeface="Calibri"/>
               </a:defRPr>
@@ -7590,7 +7633,7 @@
               </a:spcAft>
               <a:defRPr sz="1100" b="0">
                 <a:solidFill>
-                  <a:srgbClr val="D9DBD8"/>
+                  <a:srgbClr val="3A3A3C"/>
                 </a:solidFill>
                 <a:latin typeface="Calibri"/>
               </a:defRPr>
@@ -7606,7 +7649,7 @@
               </a:spcAft>
               <a:defRPr sz="1100" b="0">
                 <a:solidFill>
-                  <a:srgbClr val="D9DBD8"/>
+                  <a:srgbClr val="3A3A3C"/>
                 </a:solidFill>
                 <a:latin typeface="Calibri"/>
               </a:defRPr>
@@ -7622,7 +7665,7 @@
               </a:spcAft>
               <a:defRPr sz="1100" b="0">
                 <a:solidFill>
-                  <a:srgbClr val="D9DBD8"/>
+                  <a:srgbClr val="3A3A3C"/>
                 </a:solidFill>
                 <a:latin typeface="Calibri"/>
               </a:defRPr>
@@ -7650,11 +7693,11 @@
             </a:avLst>
           </a:prstGeom>
           <a:solidFill>
-            <a:srgbClr val="2A2A2C"/>
+            <a:srgbClr val="FFFFFF"/>
           </a:solidFill>
           <a:ln w="12700">
             <a:solidFill>
-              <a:srgbClr val="3A3A3C"/>
+              <a:srgbClr val="E0E0DE"/>
             </a:solidFill>
           </a:ln>
         </p:spPr>
@@ -7705,7 +7748,7 @@
             <a:pPr algn="l">
               <a:defRPr sz="1400" b="1">
                 <a:solidFill>
-                  <a:srgbClr val="FFFFFF"/>
+                  <a:srgbClr val="1C1C1E"/>
                 </a:solidFill>
                 <a:latin typeface="Calibri"/>
               </a:defRPr>
@@ -7744,7 +7787,7 @@
               </a:spcAft>
               <a:defRPr sz="1100" b="0">
                 <a:solidFill>
-                  <a:srgbClr val="D9DBD8"/>
+                  <a:srgbClr val="3A3A3C"/>
                 </a:solidFill>
                 <a:latin typeface="Calibri"/>
               </a:defRPr>
@@ -7760,7 +7803,7 @@
               </a:spcAft>
               <a:defRPr sz="1100" b="0">
                 <a:solidFill>
-                  <a:srgbClr val="D9DBD8"/>
+                  <a:srgbClr val="3A3A3C"/>
                 </a:solidFill>
                 <a:latin typeface="Calibri"/>
               </a:defRPr>
@@ -7776,7 +7819,7 @@
               </a:spcAft>
               <a:defRPr sz="1100" b="0">
                 <a:solidFill>
-                  <a:srgbClr val="D9DBD8"/>
+                  <a:srgbClr val="3A3A3C"/>
                 </a:solidFill>
                 <a:latin typeface="Calibri"/>
               </a:defRPr>
@@ -7792,7 +7835,7 @@
               </a:spcAft>
               <a:defRPr sz="1100" b="0">
                 <a:solidFill>
-                  <a:srgbClr val="D9DBD8"/>
+                  <a:srgbClr val="3A3A3C"/>
                 </a:solidFill>
                 <a:latin typeface="Calibri"/>
               </a:defRPr>
@@ -7817,7 +7860,7 @@
     <p:bg>
       <p:bgPr>
         <a:solidFill>
-          <a:srgbClr val="1C1C1E"/>
+          <a:srgbClr val="F5F5F3"/>
         </a:solidFill>
         <a:effectLst/>
       </p:bgPr>
@@ -7854,7 +7897,7 @@
             <a:pPr algn="l">
               <a:defRPr sz="1100" b="1">
                 <a:solidFill>
-                  <a:srgbClr val="E51937"/>
+                  <a:srgbClr val="767676"/>
                 </a:solidFill>
                 <a:latin typeface="Calibri"/>
               </a:defRPr>
@@ -7890,7 +7933,7 @@
             <a:pPr algn="l">
               <a:defRPr sz="3200" b="1">
                 <a:solidFill>
-                  <a:srgbClr val="FFFFFF"/>
+                  <a:srgbClr val="1C1C1E"/>
                 </a:solidFill>
                 <a:latin typeface="Calibri"/>
               </a:defRPr>
@@ -7910,7 +7953,7 @@
         <p:spPr>
           <a:xfrm>
             <a:off x="731520" y="1051560"/>
-            <a:ext cx="914400" cy="25400"/>
+            <a:ext cx="731520" cy="38100"/>
           </a:xfrm>
           <a:prstGeom prst="rect">
             <a:avLst/>
@@ -7961,11 +8004,11 @@
             </a:avLst>
           </a:prstGeom>
           <a:solidFill>
-            <a:srgbClr val="2A2A2C"/>
+            <a:srgbClr val="FFFFFF"/>
           </a:solidFill>
           <a:ln w="12700">
             <a:solidFill>
-              <a:srgbClr val="3A3A3C"/>
+              <a:srgbClr val="E0E0DE"/>
             </a:solidFill>
           </a:ln>
         </p:spPr>
@@ -8006,7 +8049,7 @@
             <a:avLst/>
           </a:prstGeom>
           <a:solidFill>
-            <a:srgbClr val="E51937"/>
+            <a:srgbClr val="1C1C1E"/>
           </a:solidFill>
           <a:ln>
             <a:noFill/>
@@ -8033,7 +8076,7 @@
             <a:pPr algn="ctr">
               <a:defRPr sz="1400" b="1">
                 <a:solidFill>
-                  <a:srgbClr val="FFFFFF"/>
+                  <a:srgbClr val="F5F5F3"/>
                 </a:solidFill>
               </a:defRPr>
             </a:pPr>
@@ -8068,7 +8111,7 @@
             <a:pPr algn="l">
               <a:defRPr sz="1000" b="1">
                 <a:solidFill>
-                  <a:srgbClr val="E51937"/>
+                  <a:srgbClr val="1C1C1E"/>
                 </a:solidFill>
                 <a:latin typeface="Calibri"/>
               </a:defRPr>
@@ -8104,7 +8147,7 @@
             <a:pPr algn="l">
               <a:defRPr sz="1100" b="0">
                 <a:solidFill>
-                  <a:srgbClr val="D9DBD8"/>
+                  <a:srgbClr val="3A3A3C"/>
                 </a:solidFill>
                 <a:latin typeface="Calibri"/>
               </a:defRPr>
@@ -8132,11 +8175,11 @@
             </a:avLst>
           </a:prstGeom>
           <a:solidFill>
-            <a:srgbClr val="2A2A2C"/>
+            <a:srgbClr val="FFFFFF"/>
           </a:solidFill>
           <a:ln w="12700">
             <a:solidFill>
-              <a:srgbClr val="3A3A3C"/>
+              <a:srgbClr val="E0E0DE"/>
             </a:solidFill>
           </a:ln>
         </p:spPr>
@@ -8177,7 +8220,7 @@
             <a:avLst/>
           </a:prstGeom>
           <a:solidFill>
-            <a:srgbClr val="E51937"/>
+            <a:srgbClr val="1C1C1E"/>
           </a:solidFill>
           <a:ln>
             <a:noFill/>
@@ -8204,7 +8247,7 @@
             <a:pPr algn="ctr">
               <a:defRPr sz="1400" b="1">
                 <a:solidFill>
-                  <a:srgbClr val="FFFFFF"/>
+                  <a:srgbClr val="F5F5F3"/>
                 </a:solidFill>
               </a:defRPr>
             </a:pPr>
@@ -8239,7 +8282,7 @@
             <a:pPr algn="l">
               <a:defRPr sz="1000" b="1">
                 <a:solidFill>
-                  <a:srgbClr val="E51937"/>
+                  <a:srgbClr val="1C1C1E"/>
                 </a:solidFill>
                 <a:latin typeface="Calibri"/>
               </a:defRPr>
@@ -8275,7 +8318,7 @@
             <a:pPr algn="l">
               <a:defRPr sz="1100" b="0">
                 <a:solidFill>
-                  <a:srgbClr val="D9DBD8"/>
+                  <a:srgbClr val="3A3A3C"/>
                 </a:solidFill>
                 <a:latin typeface="Calibri"/>
               </a:defRPr>
@@ -8303,11 +8346,11 @@
             </a:avLst>
           </a:prstGeom>
           <a:solidFill>
-            <a:srgbClr val="2A2A2C"/>
+            <a:srgbClr val="FFFFFF"/>
           </a:solidFill>
           <a:ln w="12700">
             <a:solidFill>
-              <a:srgbClr val="3A3A3C"/>
+              <a:srgbClr val="E0E0DE"/>
             </a:solidFill>
           </a:ln>
         </p:spPr>
@@ -8348,7 +8391,7 @@
             <a:avLst/>
           </a:prstGeom>
           <a:solidFill>
-            <a:srgbClr val="E51937"/>
+            <a:srgbClr val="1C1C1E"/>
           </a:solidFill>
           <a:ln>
             <a:noFill/>
@@ -8375,7 +8418,7 @@
             <a:pPr algn="ctr">
               <a:defRPr sz="1400" b="1">
                 <a:solidFill>
-                  <a:srgbClr val="FFFFFF"/>
+                  <a:srgbClr val="F5F5F3"/>
                 </a:solidFill>
               </a:defRPr>
             </a:pPr>
@@ -8410,7 +8453,7 @@
             <a:pPr algn="l">
               <a:defRPr sz="1000" b="1">
                 <a:solidFill>
-                  <a:srgbClr val="E51937"/>
+                  <a:srgbClr val="1C1C1E"/>
                 </a:solidFill>
                 <a:latin typeface="Calibri"/>
               </a:defRPr>
@@ -8446,7 +8489,7 @@
             <a:pPr algn="l">
               <a:defRPr sz="1100" b="0">
                 <a:solidFill>
-                  <a:srgbClr val="D9DBD8"/>
+                  <a:srgbClr val="3A3A3C"/>
                 </a:solidFill>
                 <a:latin typeface="Calibri"/>
               </a:defRPr>
@@ -8474,11 +8517,11 @@
             </a:avLst>
           </a:prstGeom>
           <a:solidFill>
-            <a:srgbClr val="2A2A2C"/>
+            <a:srgbClr val="FFFFFF"/>
           </a:solidFill>
           <a:ln w="12700">
             <a:solidFill>
-              <a:srgbClr val="3A3A3C"/>
+              <a:srgbClr val="E0E0DE"/>
             </a:solidFill>
           </a:ln>
         </p:spPr>
@@ -8519,7 +8562,7 @@
             <a:avLst/>
           </a:prstGeom>
           <a:solidFill>
-            <a:srgbClr val="E51937"/>
+            <a:srgbClr val="1C1C1E"/>
           </a:solidFill>
           <a:ln>
             <a:noFill/>
@@ -8546,7 +8589,7 @@
             <a:pPr algn="ctr">
               <a:defRPr sz="1400" b="1">
                 <a:solidFill>
-                  <a:srgbClr val="FFFFFF"/>
+                  <a:srgbClr val="F5F5F3"/>
                 </a:solidFill>
               </a:defRPr>
             </a:pPr>
@@ -8581,7 +8624,7 @@
             <a:pPr algn="l">
               <a:defRPr sz="1000" b="1">
                 <a:solidFill>
-                  <a:srgbClr val="E51937"/>
+                  <a:srgbClr val="1C1C1E"/>
                 </a:solidFill>
                 <a:latin typeface="Calibri"/>
               </a:defRPr>
@@ -8617,7 +8660,7 @@
             <a:pPr algn="l">
               <a:defRPr sz="1100" b="0">
                 <a:solidFill>
-                  <a:srgbClr val="D9DBD8"/>
+                  <a:srgbClr val="3A3A3C"/>
                 </a:solidFill>
                 <a:latin typeface="Calibri"/>
               </a:defRPr>
@@ -8645,11 +8688,11 @@
             </a:avLst>
           </a:prstGeom>
           <a:solidFill>
-            <a:srgbClr val="2A2A2C"/>
+            <a:srgbClr val="FFFFFF"/>
           </a:solidFill>
           <a:ln w="12700">
             <a:solidFill>
-              <a:srgbClr val="3A3A3C"/>
+              <a:srgbClr val="E0E0DE"/>
             </a:solidFill>
           </a:ln>
         </p:spPr>
@@ -8690,7 +8733,7 @@
             <a:avLst/>
           </a:prstGeom>
           <a:solidFill>
-            <a:srgbClr val="E51937"/>
+            <a:srgbClr val="1C1C1E"/>
           </a:solidFill>
           <a:ln>
             <a:noFill/>
@@ -8717,7 +8760,7 @@
             <a:pPr algn="ctr">
               <a:defRPr sz="1400" b="1">
                 <a:solidFill>
-                  <a:srgbClr val="FFFFFF"/>
+                  <a:srgbClr val="F5F5F3"/>
                 </a:solidFill>
               </a:defRPr>
             </a:pPr>
@@ -8752,7 +8795,7 @@
             <a:pPr algn="l">
               <a:defRPr sz="1000" b="1">
                 <a:solidFill>
-                  <a:srgbClr val="E51937"/>
+                  <a:srgbClr val="1C1C1E"/>
                 </a:solidFill>
                 <a:latin typeface="Calibri"/>
               </a:defRPr>
@@ -8788,7 +8831,7 @@
             <a:pPr algn="l">
               <a:defRPr sz="1100" b="0">
                 <a:solidFill>
-                  <a:srgbClr val="D9DBD8"/>
+                  <a:srgbClr val="3A3A3C"/>
                 </a:solidFill>
                 <a:latin typeface="Calibri"/>
               </a:defRPr>
@@ -8816,11 +8859,11 @@
             </a:avLst>
           </a:prstGeom>
           <a:solidFill>
-            <a:srgbClr val="2A2A2C"/>
+            <a:srgbClr val="FFFFFF"/>
           </a:solidFill>
           <a:ln w="12700">
             <a:solidFill>
-              <a:srgbClr val="3A3A3C"/>
+              <a:srgbClr val="E0E0DE"/>
             </a:solidFill>
           </a:ln>
         </p:spPr>
@@ -8871,7 +8914,7 @@
             <a:pPr algn="l">
               <a:defRPr sz="1400" b="1">
                 <a:solidFill>
-                  <a:srgbClr val="FFFFFF"/>
+                  <a:srgbClr val="1C1C1E"/>
                 </a:solidFill>
                 <a:latin typeface="Calibri"/>
               </a:defRPr>
@@ -8910,7 +8953,7 @@
               </a:spcAft>
               <a:defRPr sz="1100" b="0">
                 <a:solidFill>
-                  <a:srgbClr val="D9DBD8"/>
+                  <a:srgbClr val="3A3A3C"/>
                 </a:solidFill>
                 <a:latin typeface="Calibri"/>
               </a:defRPr>
@@ -8926,7 +8969,7 @@
               </a:spcAft>
               <a:defRPr sz="1100" b="0">
                 <a:solidFill>
-                  <a:srgbClr val="D9DBD8"/>
+                  <a:srgbClr val="3A3A3C"/>
                 </a:solidFill>
                 <a:latin typeface="Calibri"/>
               </a:defRPr>
@@ -8942,7 +8985,7 @@
               </a:spcAft>
               <a:defRPr sz="1100" b="0">
                 <a:solidFill>
-                  <a:srgbClr val="D9DBD8"/>
+                  <a:srgbClr val="3A3A3C"/>
                 </a:solidFill>
                 <a:latin typeface="Calibri"/>
               </a:defRPr>
@@ -8958,7 +9001,7 @@
               </a:spcAft>
               <a:defRPr sz="1100" b="0">
                 <a:solidFill>
-                  <a:srgbClr val="D9DBD8"/>
+                  <a:srgbClr val="3A3A3C"/>
                 </a:solidFill>
                 <a:latin typeface="Calibri"/>
               </a:defRPr>
@@ -8986,11 +9029,11 @@
             </a:avLst>
           </a:prstGeom>
           <a:solidFill>
-            <a:srgbClr val="2A2A2C"/>
+            <a:srgbClr val="FFFFFF"/>
           </a:solidFill>
           <a:ln w="12700">
             <a:solidFill>
-              <a:srgbClr val="3A3A3C"/>
+              <a:srgbClr val="E0E0DE"/>
             </a:solidFill>
           </a:ln>
         </p:spPr>
@@ -9041,7 +9084,7 @@
             <a:pPr algn="l">
               <a:defRPr sz="1400" b="1">
                 <a:solidFill>
-                  <a:srgbClr val="FFFFFF"/>
+                  <a:srgbClr val="1C1C1E"/>
                 </a:solidFill>
                 <a:latin typeface="Calibri"/>
               </a:defRPr>
@@ -9080,7 +9123,7 @@
               </a:spcAft>
               <a:defRPr sz="1100" b="0">
                 <a:solidFill>
-                  <a:srgbClr val="D9DBD8"/>
+                  <a:srgbClr val="3A3A3C"/>
                 </a:solidFill>
                 <a:latin typeface="Calibri"/>
               </a:defRPr>
@@ -9096,7 +9139,7 @@
               </a:spcAft>
               <a:defRPr sz="1100" b="0">
                 <a:solidFill>
-                  <a:srgbClr val="D9DBD8"/>
+                  <a:srgbClr val="3A3A3C"/>
                 </a:solidFill>
                 <a:latin typeface="Calibri"/>
               </a:defRPr>
@@ -9112,7 +9155,7 @@
               </a:spcAft>
               <a:defRPr sz="1100" b="0">
                 <a:solidFill>
-                  <a:srgbClr val="D9DBD8"/>
+                  <a:srgbClr val="3A3A3C"/>
                 </a:solidFill>
                 <a:latin typeface="Calibri"/>
               </a:defRPr>
@@ -9128,7 +9171,7 @@
               </a:spcAft>
               <a:defRPr sz="1100" b="0">
                 <a:solidFill>
-                  <a:srgbClr val="D9DBD8"/>
+                  <a:srgbClr val="3A3A3C"/>
                 </a:solidFill>
                 <a:latin typeface="Calibri"/>
               </a:defRPr>
@@ -9153,7 +9196,7 @@
     <p:bg>
       <p:bgPr>
         <a:solidFill>
-          <a:srgbClr val="1C1C1E"/>
+          <a:srgbClr val="F5F5F3"/>
         </a:solidFill>
         <a:effectLst/>
       </p:bgPr>
@@ -9190,7 +9233,7 @@
             <a:pPr algn="l">
               <a:defRPr sz="1100" b="1">
                 <a:solidFill>
-                  <a:srgbClr val="E51937"/>
+                  <a:srgbClr val="767676"/>
                 </a:solidFill>
                 <a:latin typeface="Calibri"/>
               </a:defRPr>
@@ -9226,7 +9269,7 @@
             <a:pPr algn="l">
               <a:defRPr sz="3200" b="1">
                 <a:solidFill>
-                  <a:srgbClr val="FFFFFF"/>
+                  <a:srgbClr val="1C1C1E"/>
                 </a:solidFill>
                 <a:latin typeface="Calibri"/>
               </a:defRPr>
@@ -9246,7 +9289,7 @@
         <p:spPr>
           <a:xfrm>
             <a:off x="731520" y="1051560"/>
-            <a:ext cx="914400" cy="25400"/>
+            <a:ext cx="731520" cy="38100"/>
           </a:xfrm>
           <a:prstGeom prst="rect">
             <a:avLst/>
@@ -9305,7 +9348,7 @@
             <a:pPr algn="l">
               <a:defRPr sz="1600" b="1">
                 <a:solidFill>
-                  <a:srgbClr val="FFFFFF"/>
+                  <a:srgbClr val="1C1C1E"/>
                 </a:solidFill>
                 <a:latin typeface="Calibri"/>
               </a:defRPr>
@@ -9341,7 +9384,7 @@
             <a:pPr algn="l">
               <a:defRPr sz="1200" b="0">
                 <a:solidFill>
-                  <a:srgbClr val="D9DBD8"/>
+                  <a:srgbClr val="3A3A3C"/>
                 </a:solidFill>
                 <a:latin typeface="Calibri"/>
               </a:defRPr>
@@ -9377,7 +9420,7 @@
             <a:pPr algn="l">
               <a:defRPr sz="1200" b="1">
                 <a:solidFill>
-                  <a:srgbClr val="E51937"/>
+                  <a:srgbClr val="1C1C1E"/>
                 </a:solidFill>
                 <a:latin typeface="Calibri"/>
               </a:defRPr>
@@ -9413,7 +9456,7 @@
             <a:pPr algn="l">
               <a:defRPr sz="1200" b="0">
                 <a:solidFill>
-                  <a:srgbClr val="D9DBD8"/>
+                  <a:srgbClr val="3A3A3C"/>
                 </a:solidFill>
                 <a:latin typeface="Calibri"/>
               </a:defRPr>
@@ -9449,7 +9492,7 @@
             <a:pPr algn="l">
               <a:defRPr sz="1200" b="1">
                 <a:solidFill>
-                  <a:srgbClr val="E51937"/>
+                  <a:srgbClr val="1C1C1E"/>
                 </a:solidFill>
                 <a:latin typeface="Calibri"/>
               </a:defRPr>
@@ -9485,7 +9528,7 @@
             <a:pPr algn="l">
               <a:defRPr sz="1200" b="0">
                 <a:solidFill>
-                  <a:srgbClr val="D9DBD8"/>
+                  <a:srgbClr val="3A3A3C"/>
                 </a:solidFill>
                 <a:latin typeface="Calibri"/>
               </a:defRPr>
@@ -9521,7 +9564,7 @@
             <a:pPr algn="l">
               <a:defRPr sz="1200" b="1">
                 <a:solidFill>
-                  <a:srgbClr val="E51937"/>
+                  <a:srgbClr val="1C1C1E"/>
                 </a:solidFill>
                 <a:latin typeface="Calibri"/>
               </a:defRPr>
@@ -9557,7 +9600,7 @@
             <a:pPr algn="l">
               <a:defRPr sz="1200" b="0">
                 <a:solidFill>
-                  <a:srgbClr val="D9DBD8"/>
+                  <a:srgbClr val="3A3A3C"/>
                 </a:solidFill>
                 <a:latin typeface="Calibri"/>
               </a:defRPr>
@@ -9593,7 +9636,7 @@
             <a:pPr algn="l">
               <a:defRPr sz="1200" b="1">
                 <a:solidFill>
-                  <a:srgbClr val="E51937"/>
+                  <a:srgbClr val="1C1C1E"/>
                 </a:solidFill>
                 <a:latin typeface="Calibri"/>
               </a:defRPr>
@@ -9629,7 +9672,7 @@
             <a:pPr algn="l">
               <a:defRPr sz="1200" b="0">
                 <a:solidFill>
-                  <a:srgbClr val="D9DBD8"/>
+                  <a:srgbClr val="3A3A3C"/>
                 </a:solidFill>
                 <a:latin typeface="Calibri"/>
               </a:defRPr>
@@ -9665,7 +9708,7 @@
             <a:pPr algn="l">
               <a:defRPr sz="1200" b="1">
                 <a:solidFill>
-                  <a:srgbClr val="E51937"/>
+                  <a:srgbClr val="1C1C1E"/>
                 </a:solidFill>
                 <a:latin typeface="Calibri"/>
               </a:defRPr>
@@ -9701,7 +9744,7 @@
             <a:pPr algn="l">
               <a:defRPr sz="1600" b="1">
                 <a:solidFill>
-                  <a:srgbClr val="FFFFFF"/>
+                  <a:srgbClr val="1C1C1E"/>
                 </a:solidFill>
                 <a:latin typeface="Calibri"/>
               </a:defRPr>
@@ -9729,11 +9772,11 @@
             </a:avLst>
           </a:prstGeom>
           <a:solidFill>
-            <a:srgbClr val="2A2A2C"/>
+            <a:srgbClr val="FFFFFF"/>
           </a:solidFill>
           <a:ln w="12700">
             <a:solidFill>
-              <a:srgbClr val="3A3A3C"/>
+              <a:srgbClr val="E0E0DE"/>
             </a:solidFill>
           </a:ln>
         </p:spPr>
@@ -9820,7 +9863,7 @@
             <a:pPr algn="l">
               <a:defRPr sz="2600" b="1">
                 <a:solidFill>
-                  <a:srgbClr val="E51937"/>
+                  <a:srgbClr val="1C1C1E"/>
                 </a:solidFill>
                 <a:latin typeface="Calibri"/>
               </a:defRPr>
@@ -9884,11 +9927,11 @@
             </a:avLst>
           </a:prstGeom>
           <a:solidFill>
-            <a:srgbClr val="2A2A2C"/>
+            <a:srgbClr val="FFFFFF"/>
           </a:solidFill>
           <a:ln w="12700">
             <a:solidFill>
-              <a:srgbClr val="3A3A3C"/>
+              <a:srgbClr val="E0E0DE"/>
             </a:solidFill>
           </a:ln>
         </p:spPr>
@@ -9975,7 +10018,7 @@
             <a:pPr algn="l">
               <a:defRPr sz="2600" b="1">
                 <a:solidFill>
-                  <a:srgbClr val="E51937"/>
+                  <a:srgbClr val="1C1C1E"/>
                 </a:solidFill>
                 <a:latin typeface="Calibri"/>
               </a:defRPr>
@@ -10050,7 +10093,7 @@
               </a:spcAft>
               <a:defRPr sz="1300" b="1">
                 <a:solidFill>
-                  <a:srgbClr val="FFFFFF"/>
+                  <a:srgbClr val="1C1C1E"/>
                 </a:solidFill>
                 <a:latin typeface="Calibri"/>
               </a:defRPr>
@@ -10066,7 +10109,7 @@
               </a:spcAft>
               <a:defRPr sz="1100" b="0">
                 <a:solidFill>
-                  <a:srgbClr val="D9DBD8"/>
+                  <a:srgbClr val="3A3A3C"/>
                 </a:solidFill>
                 <a:latin typeface="Calibri"/>
               </a:defRPr>
@@ -10082,7 +10125,7 @@
               </a:spcAft>
               <a:defRPr sz="1100" b="0">
                 <a:solidFill>
-                  <a:srgbClr val="D9DBD8"/>
+                  <a:srgbClr val="3A3A3C"/>
                 </a:solidFill>
                 <a:latin typeface="Calibri"/>
               </a:defRPr>
@@ -10098,7 +10141,7 @@
               </a:spcAft>
               <a:defRPr sz="1100" b="0">
                 <a:solidFill>
-                  <a:srgbClr val="D9DBD8"/>
+                  <a:srgbClr val="3A3A3C"/>
                 </a:solidFill>
                 <a:latin typeface="Calibri"/>
               </a:defRPr>
@@ -10127,7 +10170,7 @@
               </a:spcAft>
               <a:defRPr sz="1300" b="1">
                 <a:solidFill>
-                  <a:srgbClr val="FFFFFF"/>
+                  <a:srgbClr val="1C1C1E"/>
                 </a:solidFill>
                 <a:latin typeface="Calibri"/>
               </a:defRPr>
@@ -10143,7 +10186,7 @@
               </a:spcAft>
               <a:defRPr sz="1100" b="0">
                 <a:solidFill>
-                  <a:srgbClr val="D9DBD8"/>
+                  <a:srgbClr val="3A3A3C"/>
                 </a:solidFill>
                 <a:latin typeface="Calibri"/>
               </a:defRPr>
@@ -10159,7 +10202,7 @@
               </a:spcAft>
               <a:defRPr sz="1100" b="0">
                 <a:solidFill>
-                  <a:srgbClr val="D9DBD8"/>
+                  <a:srgbClr val="3A3A3C"/>
                 </a:solidFill>
                 <a:latin typeface="Calibri"/>
               </a:defRPr>
@@ -10175,7 +10218,7 @@
               </a:spcAft>
               <a:defRPr sz="1100" b="0">
                 <a:solidFill>
-                  <a:srgbClr val="D9DBD8"/>
+                  <a:srgbClr val="3A3A3C"/>
                 </a:solidFill>
                 <a:latin typeface="Calibri"/>
               </a:defRPr>
@@ -10204,7 +10247,7 @@
               </a:spcAft>
               <a:defRPr sz="1200" b="1">
                 <a:solidFill>
-                  <a:srgbClr val="FFFFFF"/>
+                  <a:srgbClr val="1C1C1E"/>
                 </a:solidFill>
                 <a:latin typeface="Calibri"/>
               </a:defRPr>
@@ -10236,7 +10279,7 @@
               </a:spcAft>
               <a:defRPr sz="1200" b="1">
                 <a:solidFill>
-                  <a:srgbClr val="E51937"/>
+                  <a:srgbClr val="1C1C1E"/>
                 </a:solidFill>
                 <a:latin typeface="Calibri"/>
               </a:defRPr>
@@ -10261,7 +10304,7 @@
     <p:bg>
       <p:bgPr>
         <a:solidFill>
-          <a:srgbClr val="1C1C1E"/>
+          <a:srgbClr val="F5F5F3"/>
         </a:solidFill>
         <a:effectLst/>
       </p:bgPr>
@@ -10298,7 +10341,7 @@
             <a:pPr algn="l">
               <a:defRPr sz="1100" b="1">
                 <a:solidFill>
-                  <a:srgbClr val="E51937"/>
+                  <a:srgbClr val="767676"/>
                 </a:solidFill>
                 <a:latin typeface="Calibri"/>
               </a:defRPr>
@@ -10334,7 +10377,7 @@
             <a:pPr algn="l">
               <a:defRPr sz="3200" b="1">
                 <a:solidFill>
-                  <a:srgbClr val="FFFFFF"/>
+                  <a:srgbClr val="1C1C1E"/>
                 </a:solidFill>
                 <a:latin typeface="Calibri"/>
               </a:defRPr>
@@ -10354,7 +10397,7 @@
         <p:spPr>
           <a:xfrm>
             <a:off x="731520" y="1051560"/>
-            <a:ext cx="914400" cy="25400"/>
+            <a:ext cx="731520" cy="38100"/>
           </a:xfrm>
           <a:prstGeom prst="rect">
             <a:avLst/>
@@ -10413,7 +10456,7 @@
             <a:pPr algn="l">
               <a:defRPr sz="1400" b="0">
                 <a:solidFill>
-                  <a:srgbClr val="D9DBD8"/>
+                  <a:srgbClr val="3A3A3C"/>
                 </a:solidFill>
                 <a:latin typeface="Calibri"/>
               </a:defRPr>
@@ -10441,11 +10484,11 @@
             </a:avLst>
           </a:prstGeom>
           <a:solidFill>
-            <a:srgbClr val="2A2A2C"/>
+            <a:srgbClr val="FFFFFF"/>
           </a:solidFill>
           <a:ln w="12700">
             <a:solidFill>
-              <a:srgbClr val="3A3A3C"/>
+              <a:srgbClr val="E0E0DE"/>
             </a:solidFill>
           </a:ln>
         </p:spPr>
@@ -10496,7 +10539,7 @@
             <a:pPr algn="l">
               <a:defRPr sz="1500" b="1">
                 <a:solidFill>
-                  <a:srgbClr val="E51937"/>
+                  <a:srgbClr val="1C1C1E"/>
                 </a:solidFill>
                 <a:latin typeface="Calibri"/>
               </a:defRPr>
@@ -10532,7 +10575,7 @@
             <a:pPr algn="l">
               <a:defRPr sz="1200" b="0">
                 <a:solidFill>
-                  <a:srgbClr val="D9DBD8"/>
+                  <a:srgbClr val="3A3A3C"/>
                 </a:solidFill>
                 <a:latin typeface="Calibri"/>
               </a:defRPr>
@@ -10560,11 +10603,11 @@
             </a:avLst>
           </a:prstGeom>
           <a:solidFill>
-            <a:srgbClr val="2A2A2C"/>
+            <a:srgbClr val="FFFFFF"/>
           </a:solidFill>
           <a:ln w="12700">
             <a:solidFill>
-              <a:srgbClr val="3A3A3C"/>
+              <a:srgbClr val="E0E0DE"/>
             </a:solidFill>
           </a:ln>
         </p:spPr>
@@ -10615,7 +10658,7 @@
             <a:pPr algn="l">
               <a:defRPr sz="1500" b="1">
                 <a:solidFill>
-                  <a:srgbClr val="E51937"/>
+                  <a:srgbClr val="1C1C1E"/>
                 </a:solidFill>
                 <a:latin typeface="Calibri"/>
               </a:defRPr>
@@ -10651,7 +10694,7 @@
             <a:pPr algn="l">
               <a:defRPr sz="1200" b="0">
                 <a:solidFill>
-                  <a:srgbClr val="D9DBD8"/>
+                  <a:srgbClr val="3A3A3C"/>
                 </a:solidFill>
                 <a:latin typeface="Calibri"/>
               </a:defRPr>
@@ -10679,11 +10722,11 @@
             </a:avLst>
           </a:prstGeom>
           <a:solidFill>
-            <a:srgbClr val="2A2A2C"/>
+            <a:srgbClr val="FFFFFF"/>
           </a:solidFill>
           <a:ln w="12700">
             <a:solidFill>
-              <a:srgbClr val="3A3A3C"/>
+              <a:srgbClr val="E0E0DE"/>
             </a:solidFill>
           </a:ln>
         </p:spPr>
@@ -10734,7 +10777,7 @@
             <a:pPr algn="l">
               <a:defRPr sz="1500" b="1">
                 <a:solidFill>
-                  <a:srgbClr val="E51937"/>
+                  <a:srgbClr val="1C1C1E"/>
                 </a:solidFill>
                 <a:latin typeface="Calibri"/>
               </a:defRPr>
@@ -10770,7 +10813,7 @@
             <a:pPr algn="l">
               <a:defRPr sz="1200" b="0">
                 <a:solidFill>
-                  <a:srgbClr val="D9DBD8"/>
+                  <a:srgbClr val="3A3A3C"/>
                 </a:solidFill>
                 <a:latin typeface="Calibri"/>
               </a:defRPr>
@@ -10798,11 +10841,11 @@
             </a:avLst>
           </a:prstGeom>
           <a:solidFill>
-            <a:srgbClr val="2A2A2C"/>
+            <a:srgbClr val="FFFFFF"/>
           </a:solidFill>
           <a:ln w="12700">
             <a:solidFill>
-              <a:srgbClr val="3A3A3C"/>
+              <a:srgbClr val="E0E0DE"/>
             </a:solidFill>
           </a:ln>
         </p:spPr>
@@ -10853,7 +10896,7 @@
             <a:pPr algn="l">
               <a:defRPr sz="1500" b="1">
                 <a:solidFill>
-                  <a:srgbClr val="E51937"/>
+                  <a:srgbClr val="1C1C1E"/>
                 </a:solidFill>
                 <a:latin typeface="Calibri"/>
               </a:defRPr>
@@ -10889,7 +10932,7 @@
             <a:pPr algn="l">
               <a:defRPr sz="1200" b="0">
                 <a:solidFill>
-                  <a:srgbClr val="D9DBD8"/>
+                  <a:srgbClr val="3A3A3C"/>
                 </a:solidFill>
                 <a:latin typeface="Calibri"/>
               </a:defRPr>
@@ -10917,11 +10960,11 @@
             </a:avLst>
           </a:prstGeom>
           <a:solidFill>
-            <a:srgbClr val="2A2A2C"/>
+            <a:srgbClr val="FFFFFF"/>
           </a:solidFill>
           <a:ln w="12700">
             <a:solidFill>
-              <a:srgbClr val="E51937"/>
+              <a:srgbClr val="E0E0DE"/>
             </a:solidFill>
           </a:ln>
         </p:spPr>
@@ -10949,7 +10992,50 @@
       </p:sp>
       <p:sp>
         <p:nvSpPr>
-          <p:cNvPr id="19" name="TextBox 18"/>
+          <p:cNvPr id="19" name="Rectangle 18"/>
+          <p:cNvSpPr/>
+          <p:nvPr/>
+        </p:nvSpPr>
+        <p:spPr>
+          <a:xfrm>
+            <a:off x="731520" y="5943600"/>
+            <a:ext cx="50800" cy="411480"/>
+          </a:xfrm>
+          <a:prstGeom prst="rect">
+            <a:avLst/>
+          </a:prstGeom>
+          <a:solidFill>
+            <a:srgbClr val="E51937"/>
+          </a:solidFill>
+          <a:ln>
+            <a:noFill/>
+          </a:ln>
+        </p:spPr>
+        <p:style>
+          <a:lnRef idx="1">
+            <a:schemeClr val="accent1"/>
+          </a:lnRef>
+          <a:fillRef idx="3">
+            <a:schemeClr val="accent1"/>
+          </a:fillRef>
+          <a:effectRef idx="2">
+            <a:schemeClr val="accent1"/>
+          </a:effectRef>
+          <a:fontRef idx="minor">
+            <a:schemeClr val="lt1"/>
+          </a:fontRef>
+        </p:style>
+        <p:txBody>
+          <a:bodyPr rtlCol="0" anchor="ctr"/>
+          <a:lstStyle/>
+          <a:p>
+            <a:pPr algn="ctr"/>
+          </a:p>
+        </p:txBody>
+      </p:sp>
+      <p:sp>
+        <p:nvSpPr>
+          <p:cNvPr id="20" name="TextBox 19"/>
           <p:cNvSpPr txBox="1"/>
           <p:nvPr/>
         </p:nvSpPr>
@@ -10972,7 +11058,7 @@
             <a:pPr algn="ctr">
               <a:defRPr sz="1300" b="1">
                 <a:solidFill>
-                  <a:srgbClr val="E51937"/>
+                  <a:srgbClr val="1C1C1E"/>
                 </a:solidFill>
                 <a:latin typeface="Calibri"/>
               </a:defRPr>
@@ -10997,7 +11083,7 @@
     <p:bg>
       <p:bgPr>
         <a:solidFill>
-          <a:srgbClr val="1C1C1E"/>
+          <a:srgbClr val="F5F5F3"/>
         </a:solidFill>
         <a:effectLst/>
       </p:bgPr>
@@ -11034,7 +11120,7 @@
             <a:pPr algn="l">
               <a:defRPr sz="1100" b="1">
                 <a:solidFill>
-                  <a:srgbClr val="E51937"/>
+                  <a:srgbClr val="767676"/>
                 </a:solidFill>
                 <a:latin typeface="Calibri"/>
               </a:defRPr>
@@ -11070,7 +11156,7 @@
             <a:pPr algn="l">
               <a:defRPr sz="3200" b="1">
                 <a:solidFill>
-                  <a:srgbClr val="FFFFFF"/>
+                  <a:srgbClr val="1C1C1E"/>
                 </a:solidFill>
                 <a:latin typeface="Calibri"/>
               </a:defRPr>
@@ -11090,7 +11176,7 @@
         <p:spPr>
           <a:xfrm>
             <a:off x="731520" y="1051560"/>
-            <a:ext cx="914400" cy="25400"/>
+            <a:ext cx="731520" cy="38100"/>
           </a:xfrm>
           <a:prstGeom prst="rect">
             <a:avLst/>
@@ -11141,11 +11227,11 @@
             </a:avLst>
           </a:prstGeom>
           <a:solidFill>
-            <a:srgbClr val="2A2A2C"/>
+            <a:srgbClr val="FFFFFF"/>
           </a:solidFill>
           <a:ln w="12700">
             <a:solidFill>
-              <a:srgbClr val="3A3A3C"/>
+              <a:srgbClr val="E0E0DE"/>
             </a:solidFill>
           </a:ln>
         </p:spPr>
@@ -11183,6 +11269,519 @@
             <a:ext cx="457200" cy="457200"/>
           </a:xfrm>
           <a:prstGeom prst="ellipse">
+            <a:avLst/>
+          </a:prstGeom>
+          <a:solidFill>
+            <a:srgbClr val="1C1C1E"/>
+          </a:solidFill>
+          <a:ln>
+            <a:noFill/>
+          </a:ln>
+        </p:spPr>
+        <p:style>
+          <a:lnRef idx="1">
+            <a:schemeClr val="accent1"/>
+          </a:lnRef>
+          <a:fillRef idx="3">
+            <a:schemeClr val="accent1"/>
+          </a:fillRef>
+          <a:effectRef idx="2">
+            <a:schemeClr val="accent1"/>
+          </a:effectRef>
+          <a:fontRef idx="minor">
+            <a:schemeClr val="lt1"/>
+          </a:fontRef>
+        </p:style>
+        <p:txBody>
+          <a:bodyPr rtlCol="0" anchor="ctr"/>
+          <a:lstStyle/>
+          <a:p>
+            <a:pPr algn="ctr">
+              <a:defRPr sz="1800" b="1">
+                <a:solidFill>
+                  <a:srgbClr val="F5F5F3"/>
+                </a:solidFill>
+              </a:defRPr>
+            </a:pPr>
+            <a:r>
+              <a:t>1</a:t>
+            </a:r>
+          </a:p>
+        </p:txBody>
+      </p:sp>
+      <p:sp>
+        <p:nvSpPr>
+          <p:cNvPr id="7" name="TextBox 6"/>
+          <p:cNvSpPr txBox="1"/>
+          <p:nvPr/>
+        </p:nvSpPr>
+        <p:spPr>
+          <a:xfrm>
+            <a:off x="1828800" y="1481328"/>
+            <a:ext cx="8961120" cy="365760"/>
+          </a:xfrm>
+          <a:prstGeom prst="rect">
+            <a:avLst/>
+          </a:prstGeom>
+          <a:noFill/>
+        </p:spPr>
+        <p:txBody>
+          <a:bodyPr wrap="square">
+            <a:spAutoFit/>
+          </a:bodyPr>
+          <a:lstStyle/>
+          <a:p>
+            <a:pPr algn="l">
+              <a:defRPr sz="1800" b="1">
+                <a:solidFill>
+                  <a:srgbClr val="1C1C1E"/>
+                </a:solidFill>
+                <a:latin typeface="Calibri"/>
+              </a:defRPr>
+            </a:pPr>
+            <a:r>
+              <a:t>Launch the 90-Day Support Pilot</a:t>
+            </a:r>
+          </a:p>
+        </p:txBody>
+      </p:sp>
+      <p:sp>
+        <p:nvSpPr>
+          <p:cNvPr id="8" name="TextBox 7"/>
+          <p:cNvSpPr txBox="1"/>
+          <p:nvPr/>
+        </p:nvSpPr>
+        <p:spPr>
+          <a:xfrm>
+            <a:off x="1828800" y="1874520"/>
+            <a:ext cx="8961120" cy="594360"/>
+          </a:xfrm>
+          <a:prstGeom prst="rect">
+            <a:avLst/>
+          </a:prstGeom>
+          <a:noFill/>
+        </p:spPr>
+        <p:txBody>
+          <a:bodyPr wrap="square">
+            <a:spAutoFit/>
+          </a:bodyPr>
+          <a:lstStyle/>
+          <a:p>
+            <a:pPr algn="l">
+              <a:defRPr sz="1200" b="0">
+                <a:solidFill>
+                  <a:srgbClr val="3A3A3C"/>
+                </a:solidFill>
+                <a:latin typeface="Calibri"/>
+              </a:defRPr>
+            </a:pPr>
+            <a:r>
+              <a:t>Scope it to AXS and Hammerhead dealer support. One product owner, one integration engineer. Human approval on all outputs. Weekly quality reviews.</a:t>
+            </a:r>
+          </a:p>
+        </p:txBody>
+      </p:sp>
+      <p:sp>
+        <p:nvSpPr>
+          <p:cNvPr id="9" name="Rounded Rectangle 8"/>
+          <p:cNvSpPr/>
+          <p:nvPr/>
+        </p:nvSpPr>
+        <p:spPr>
+          <a:xfrm>
+            <a:off x="731520" y="2834640"/>
+            <a:ext cx="10515600" cy="1234440"/>
+          </a:xfrm>
+          <a:prstGeom prst="roundRect">
+            <a:avLst>
+              <a:gd name="adj" fmla="val 4000"/>
+            </a:avLst>
+          </a:prstGeom>
+          <a:solidFill>
+            <a:srgbClr val="FFFFFF"/>
+          </a:solidFill>
+          <a:ln w="12700">
+            <a:solidFill>
+              <a:srgbClr val="E0E0DE"/>
+            </a:solidFill>
+          </a:ln>
+        </p:spPr>
+        <p:style>
+          <a:lnRef idx="1">
+            <a:schemeClr val="accent1"/>
+          </a:lnRef>
+          <a:fillRef idx="3">
+            <a:schemeClr val="accent1"/>
+          </a:fillRef>
+          <a:effectRef idx="2">
+            <a:schemeClr val="accent1"/>
+          </a:effectRef>
+          <a:fontRef idx="minor">
+            <a:schemeClr val="lt1"/>
+          </a:fontRef>
+        </p:style>
+        <p:txBody>
+          <a:bodyPr rtlCol="0" anchor="ctr"/>
+          <a:lstStyle/>
+          <a:p>
+            <a:pPr algn="ctr"/>
+          </a:p>
+        </p:txBody>
+      </p:sp>
+      <p:sp>
+        <p:nvSpPr>
+          <p:cNvPr id="10" name="Oval 9"/>
+          <p:cNvSpPr/>
+          <p:nvPr/>
+        </p:nvSpPr>
+        <p:spPr>
+          <a:xfrm>
+            <a:off x="1097280" y="3090672"/>
+            <a:ext cx="457200" cy="457200"/>
+          </a:xfrm>
+          <a:prstGeom prst="ellipse">
+            <a:avLst/>
+          </a:prstGeom>
+          <a:solidFill>
+            <a:srgbClr val="1C1C1E"/>
+          </a:solidFill>
+          <a:ln>
+            <a:noFill/>
+          </a:ln>
+        </p:spPr>
+        <p:style>
+          <a:lnRef idx="1">
+            <a:schemeClr val="accent1"/>
+          </a:lnRef>
+          <a:fillRef idx="3">
+            <a:schemeClr val="accent1"/>
+          </a:fillRef>
+          <a:effectRef idx="2">
+            <a:schemeClr val="accent1"/>
+          </a:effectRef>
+          <a:fontRef idx="minor">
+            <a:schemeClr val="lt1"/>
+          </a:fontRef>
+        </p:style>
+        <p:txBody>
+          <a:bodyPr rtlCol="0" anchor="ctr"/>
+          <a:lstStyle/>
+          <a:p>
+            <a:pPr algn="ctr">
+              <a:defRPr sz="1800" b="1">
+                <a:solidFill>
+                  <a:srgbClr val="F5F5F3"/>
+                </a:solidFill>
+              </a:defRPr>
+            </a:pPr>
+            <a:r>
+              <a:t>2</a:t>
+            </a:r>
+          </a:p>
+        </p:txBody>
+      </p:sp>
+      <p:sp>
+        <p:nvSpPr>
+          <p:cNvPr id="11" name="TextBox 10"/>
+          <p:cNvSpPr txBox="1"/>
+          <p:nvPr/>
+        </p:nvSpPr>
+        <p:spPr>
+          <a:xfrm>
+            <a:off x="1828800" y="2944368"/>
+            <a:ext cx="8961120" cy="365760"/>
+          </a:xfrm>
+          <a:prstGeom prst="rect">
+            <a:avLst/>
+          </a:prstGeom>
+          <a:noFill/>
+        </p:spPr>
+        <p:txBody>
+          <a:bodyPr wrap="square">
+            <a:spAutoFit/>
+          </a:bodyPr>
+          <a:lstStyle/>
+          <a:p>
+            <a:pPr algn="l">
+              <a:defRPr sz="1800" b="1">
+                <a:solidFill>
+                  <a:srgbClr val="1C1C1E"/>
+                </a:solidFill>
+                <a:latin typeface="Calibri"/>
+              </a:defRPr>
+            </a:pPr>
+            <a:r>
+              <a:t>Begin Data Infrastructure Planning</a:t>
+            </a:r>
+          </a:p>
+        </p:txBody>
+      </p:sp>
+      <p:sp>
+        <p:nvSpPr>
+          <p:cNvPr id="12" name="TextBox 11"/>
+          <p:cNvSpPr txBox="1"/>
+          <p:nvPr/>
+        </p:nvSpPr>
+        <p:spPr>
+          <a:xfrm>
+            <a:off x="1828800" y="3337560"/>
+            <a:ext cx="8961120" cy="594360"/>
+          </a:xfrm>
+          <a:prstGeom prst="rect">
+            <a:avLst/>
+          </a:prstGeom>
+          <a:noFill/>
+        </p:spPr>
+        <p:txBody>
+          <a:bodyPr wrap="square">
+            <a:spAutoFit/>
+          </a:bodyPr>
+          <a:lstStyle/>
+          <a:p>
+            <a:pPr algn="l">
+              <a:defRPr sz="1200" b="0">
+                <a:solidFill>
+                  <a:srgbClr val="3A3A3C"/>
+                </a:solidFill>
+                <a:latin typeface="Calibri"/>
+              </a:defRPr>
+            </a:pPr>
+            <a:r>
+              <a:t>Initiate requirements for a unified data layer connecting Shopify, support systems, and telemetry data. This is the foundation for forecasting and AXS Intelligence.</a:t>
+            </a:r>
+          </a:p>
+        </p:txBody>
+      </p:sp>
+      <p:sp>
+        <p:nvSpPr>
+          <p:cNvPr id="13" name="Rounded Rectangle 12"/>
+          <p:cNvSpPr/>
+          <p:nvPr/>
+        </p:nvSpPr>
+        <p:spPr>
+          <a:xfrm>
+            <a:off x="731520" y="4297680"/>
+            <a:ext cx="10515600" cy="1234440"/>
+          </a:xfrm>
+          <a:prstGeom prst="roundRect">
+            <a:avLst>
+              <a:gd name="adj" fmla="val 4000"/>
+            </a:avLst>
+          </a:prstGeom>
+          <a:solidFill>
+            <a:srgbClr val="FFFFFF"/>
+          </a:solidFill>
+          <a:ln w="12700">
+            <a:solidFill>
+              <a:srgbClr val="E0E0DE"/>
+            </a:solidFill>
+          </a:ln>
+        </p:spPr>
+        <p:style>
+          <a:lnRef idx="1">
+            <a:schemeClr val="accent1"/>
+          </a:lnRef>
+          <a:fillRef idx="3">
+            <a:schemeClr val="accent1"/>
+          </a:fillRef>
+          <a:effectRef idx="2">
+            <a:schemeClr val="accent1"/>
+          </a:effectRef>
+          <a:fontRef idx="minor">
+            <a:schemeClr val="lt1"/>
+          </a:fontRef>
+        </p:style>
+        <p:txBody>
+          <a:bodyPr rtlCol="0" anchor="ctr"/>
+          <a:lstStyle/>
+          <a:p>
+            <a:pPr algn="ctr"/>
+          </a:p>
+        </p:txBody>
+      </p:sp>
+      <p:sp>
+        <p:nvSpPr>
+          <p:cNvPr id="14" name="Oval 13"/>
+          <p:cNvSpPr/>
+          <p:nvPr/>
+        </p:nvSpPr>
+        <p:spPr>
+          <a:xfrm>
+            <a:off x="1097280" y="4553712"/>
+            <a:ext cx="457200" cy="457200"/>
+          </a:xfrm>
+          <a:prstGeom prst="ellipse">
+            <a:avLst/>
+          </a:prstGeom>
+          <a:solidFill>
+            <a:srgbClr val="1C1C1E"/>
+          </a:solidFill>
+          <a:ln>
+            <a:noFill/>
+          </a:ln>
+        </p:spPr>
+        <p:style>
+          <a:lnRef idx="1">
+            <a:schemeClr val="accent1"/>
+          </a:lnRef>
+          <a:fillRef idx="3">
+            <a:schemeClr val="accent1"/>
+          </a:fillRef>
+          <a:effectRef idx="2">
+            <a:schemeClr val="accent1"/>
+          </a:effectRef>
+          <a:fontRef idx="minor">
+            <a:schemeClr val="lt1"/>
+          </a:fontRef>
+        </p:style>
+        <p:txBody>
+          <a:bodyPr rtlCol="0" anchor="ctr"/>
+          <a:lstStyle/>
+          <a:p>
+            <a:pPr algn="ctr">
+              <a:defRPr sz="1800" b="1">
+                <a:solidFill>
+                  <a:srgbClr val="F5F5F3"/>
+                </a:solidFill>
+              </a:defRPr>
+            </a:pPr>
+            <a:r>
+              <a:t>3</a:t>
+            </a:r>
+          </a:p>
+        </p:txBody>
+      </p:sp>
+      <p:sp>
+        <p:nvSpPr>
+          <p:cNvPr id="15" name="TextBox 14"/>
+          <p:cNvSpPr txBox="1"/>
+          <p:nvPr/>
+        </p:nvSpPr>
+        <p:spPr>
+          <a:xfrm>
+            <a:off x="1828800" y="4407408"/>
+            <a:ext cx="8961120" cy="365760"/>
+          </a:xfrm>
+          <a:prstGeom prst="rect">
+            <a:avLst/>
+          </a:prstGeom>
+          <a:noFill/>
+        </p:spPr>
+        <p:txBody>
+          <a:bodyPr wrap="square">
+            <a:spAutoFit/>
+          </a:bodyPr>
+          <a:lstStyle/>
+          <a:p>
+            <a:pPr algn="l">
+              <a:defRPr sz="1800" b="1">
+                <a:solidFill>
+                  <a:srgbClr val="1C1C1E"/>
+                </a:solidFill>
+                <a:latin typeface="Calibri"/>
+              </a:defRPr>
+            </a:pPr>
+            <a:r>
+              <a:t>Hold Sequencing Discipline</a:t>
+            </a:r>
+          </a:p>
+        </p:txBody>
+      </p:sp>
+      <p:sp>
+        <p:nvSpPr>
+          <p:cNvPr id="16" name="TextBox 15"/>
+          <p:cNvSpPr txBox="1"/>
+          <p:nvPr/>
+        </p:nvSpPr>
+        <p:spPr>
+          <a:xfrm>
+            <a:off x="1828800" y="4800600"/>
+            <a:ext cx="8961120" cy="594360"/>
+          </a:xfrm>
+          <a:prstGeom prst="rect">
+            <a:avLst/>
+          </a:prstGeom>
+          <a:noFill/>
+        </p:spPr>
+        <p:txBody>
+          <a:bodyPr wrap="square">
+            <a:spAutoFit/>
+          </a:bodyPr>
+          <a:lstStyle/>
+          <a:p>
+            <a:pPr algn="l">
+              <a:defRPr sz="1200" b="0">
+                <a:solidFill>
+                  <a:srgbClr val="3A3A3C"/>
+                </a:solidFill>
+                <a:latin typeface="Calibri"/>
+              </a:defRPr>
+            </a:pPr>
+            <a:r>
+              <a:t>Bounded, well-defined problems first. Broader transformation after measured proof. The 90-day pilot produces data to justify or redirect every subsequent investment.</a:t>
+            </a:r>
+          </a:p>
+        </p:txBody>
+      </p:sp>
+      <p:sp>
+        <p:nvSpPr>
+          <p:cNvPr id="17" name="Rounded Rectangle 16"/>
+          <p:cNvSpPr/>
+          <p:nvPr/>
+        </p:nvSpPr>
+        <p:spPr>
+          <a:xfrm>
+            <a:off x="731520" y="5897880"/>
+            <a:ext cx="10515600" cy="365760"/>
+          </a:xfrm>
+          <a:prstGeom prst="roundRect">
+            <a:avLst>
+              <a:gd name="adj" fmla="val 10000"/>
+            </a:avLst>
+          </a:prstGeom>
+          <a:solidFill>
+            <a:srgbClr val="FFFFFF"/>
+          </a:solidFill>
+          <a:ln w="12700">
+            <a:solidFill>
+              <a:srgbClr val="E0E0DE"/>
+            </a:solidFill>
+          </a:ln>
+        </p:spPr>
+        <p:style>
+          <a:lnRef idx="1">
+            <a:schemeClr val="accent1"/>
+          </a:lnRef>
+          <a:fillRef idx="3">
+            <a:schemeClr val="accent1"/>
+          </a:fillRef>
+          <a:effectRef idx="2">
+            <a:schemeClr val="accent1"/>
+          </a:effectRef>
+          <a:fontRef idx="minor">
+            <a:schemeClr val="lt1"/>
+          </a:fontRef>
+        </p:style>
+        <p:txBody>
+          <a:bodyPr rtlCol="0" anchor="ctr"/>
+          <a:lstStyle/>
+          <a:p>
+            <a:pPr algn="ctr"/>
+          </a:p>
+        </p:txBody>
+      </p:sp>
+      <p:sp>
+        <p:nvSpPr>
+          <p:cNvPr id="18" name="Rectangle 17"/>
+          <p:cNvSpPr/>
+          <p:nvPr/>
+        </p:nvSpPr>
+        <p:spPr>
+          <a:xfrm>
+            <a:off x="731520" y="5897880"/>
+            <a:ext cx="50800" cy="365760"/>
+          </a:xfrm>
+          <a:prstGeom prst="rect">
             <a:avLst/>
           </a:prstGeom>
           <a:solidFill>
@@ -11210,483 +11809,13 @@
           <a:bodyPr rtlCol="0" anchor="ctr"/>
           <a:lstStyle/>
           <a:p>
-            <a:pPr algn="ctr">
-              <a:defRPr sz="1800" b="1">
-                <a:solidFill>
-                  <a:srgbClr val="FFFFFF"/>
-                </a:solidFill>
-              </a:defRPr>
-            </a:pPr>
-            <a:r>
-              <a:t>1</a:t>
-            </a:r>
-          </a:p>
-        </p:txBody>
-      </p:sp>
-      <p:sp>
-        <p:nvSpPr>
-          <p:cNvPr id="7" name="TextBox 6"/>
-          <p:cNvSpPr txBox="1"/>
-          <p:nvPr/>
-        </p:nvSpPr>
-        <p:spPr>
-          <a:xfrm>
-            <a:off x="1828800" y="1481328"/>
-            <a:ext cx="8961120" cy="365760"/>
-          </a:xfrm>
-          <a:prstGeom prst="rect">
-            <a:avLst/>
-          </a:prstGeom>
-          <a:noFill/>
-        </p:spPr>
-        <p:txBody>
-          <a:bodyPr wrap="square">
-            <a:spAutoFit/>
-          </a:bodyPr>
-          <a:lstStyle/>
-          <a:p>
-            <a:pPr algn="l">
-              <a:defRPr sz="1800" b="1">
-                <a:solidFill>
-                  <a:srgbClr val="FFFFFF"/>
-                </a:solidFill>
-                <a:latin typeface="Calibri"/>
-              </a:defRPr>
-            </a:pPr>
-            <a:r>
-              <a:t>Launch the 90-Day Support Pilot</a:t>
-            </a:r>
-          </a:p>
-        </p:txBody>
-      </p:sp>
-      <p:sp>
-        <p:nvSpPr>
-          <p:cNvPr id="8" name="TextBox 7"/>
-          <p:cNvSpPr txBox="1"/>
-          <p:nvPr/>
-        </p:nvSpPr>
-        <p:spPr>
-          <a:xfrm>
-            <a:off x="1828800" y="1874520"/>
-            <a:ext cx="8961120" cy="594360"/>
-          </a:xfrm>
-          <a:prstGeom prst="rect">
-            <a:avLst/>
-          </a:prstGeom>
-          <a:noFill/>
-        </p:spPr>
-        <p:txBody>
-          <a:bodyPr wrap="square">
-            <a:spAutoFit/>
-          </a:bodyPr>
-          <a:lstStyle/>
-          <a:p>
-            <a:pPr algn="l">
-              <a:defRPr sz="1200" b="0">
-                <a:solidFill>
-                  <a:srgbClr val="D9DBD8"/>
-                </a:solidFill>
-                <a:latin typeface="Calibri"/>
-              </a:defRPr>
-            </a:pPr>
-            <a:r>
-              <a:t>Scope it to AXS and Hammerhead dealer support. One product owner, one integration engineer. Human approval on all outputs. Weekly quality reviews.</a:t>
-            </a:r>
-          </a:p>
-        </p:txBody>
-      </p:sp>
-      <p:sp>
-        <p:nvSpPr>
-          <p:cNvPr id="9" name="Rounded Rectangle 8"/>
-          <p:cNvSpPr/>
-          <p:nvPr/>
-        </p:nvSpPr>
-        <p:spPr>
-          <a:xfrm>
-            <a:off x="731520" y="2834640"/>
-            <a:ext cx="10515600" cy="1234440"/>
-          </a:xfrm>
-          <a:prstGeom prst="roundRect">
-            <a:avLst>
-              <a:gd name="adj" fmla="val 4000"/>
-            </a:avLst>
-          </a:prstGeom>
-          <a:solidFill>
-            <a:srgbClr val="2A2A2C"/>
-          </a:solidFill>
-          <a:ln w="12700">
-            <a:solidFill>
-              <a:srgbClr val="3A3A3C"/>
-            </a:solidFill>
-          </a:ln>
-        </p:spPr>
-        <p:style>
-          <a:lnRef idx="1">
-            <a:schemeClr val="accent1"/>
-          </a:lnRef>
-          <a:fillRef idx="3">
-            <a:schemeClr val="accent1"/>
-          </a:fillRef>
-          <a:effectRef idx="2">
-            <a:schemeClr val="accent1"/>
-          </a:effectRef>
-          <a:fontRef idx="minor">
-            <a:schemeClr val="lt1"/>
-          </a:fontRef>
-        </p:style>
-        <p:txBody>
-          <a:bodyPr rtlCol="0" anchor="ctr"/>
-          <a:lstStyle/>
-          <a:p>
             <a:pPr algn="ctr"/>
           </a:p>
         </p:txBody>
       </p:sp>
       <p:sp>
         <p:nvSpPr>
-          <p:cNvPr id="10" name="Oval 9"/>
-          <p:cNvSpPr/>
-          <p:nvPr/>
-        </p:nvSpPr>
-        <p:spPr>
-          <a:xfrm>
-            <a:off x="1097280" y="3090672"/>
-            <a:ext cx="457200" cy="457200"/>
-          </a:xfrm>
-          <a:prstGeom prst="ellipse">
-            <a:avLst/>
-          </a:prstGeom>
-          <a:solidFill>
-            <a:srgbClr val="E51937"/>
-          </a:solidFill>
-          <a:ln>
-            <a:noFill/>
-          </a:ln>
-        </p:spPr>
-        <p:style>
-          <a:lnRef idx="1">
-            <a:schemeClr val="accent1"/>
-          </a:lnRef>
-          <a:fillRef idx="3">
-            <a:schemeClr val="accent1"/>
-          </a:fillRef>
-          <a:effectRef idx="2">
-            <a:schemeClr val="accent1"/>
-          </a:effectRef>
-          <a:fontRef idx="minor">
-            <a:schemeClr val="lt1"/>
-          </a:fontRef>
-        </p:style>
-        <p:txBody>
-          <a:bodyPr rtlCol="0" anchor="ctr"/>
-          <a:lstStyle/>
-          <a:p>
-            <a:pPr algn="ctr">
-              <a:defRPr sz="1800" b="1">
-                <a:solidFill>
-                  <a:srgbClr val="FFFFFF"/>
-                </a:solidFill>
-              </a:defRPr>
-            </a:pPr>
-            <a:r>
-              <a:t>2</a:t>
-            </a:r>
-          </a:p>
-        </p:txBody>
-      </p:sp>
-      <p:sp>
-        <p:nvSpPr>
-          <p:cNvPr id="11" name="TextBox 10"/>
-          <p:cNvSpPr txBox="1"/>
-          <p:nvPr/>
-        </p:nvSpPr>
-        <p:spPr>
-          <a:xfrm>
-            <a:off x="1828800" y="2944368"/>
-            <a:ext cx="8961120" cy="365760"/>
-          </a:xfrm>
-          <a:prstGeom prst="rect">
-            <a:avLst/>
-          </a:prstGeom>
-          <a:noFill/>
-        </p:spPr>
-        <p:txBody>
-          <a:bodyPr wrap="square">
-            <a:spAutoFit/>
-          </a:bodyPr>
-          <a:lstStyle/>
-          <a:p>
-            <a:pPr algn="l">
-              <a:defRPr sz="1800" b="1">
-                <a:solidFill>
-                  <a:srgbClr val="FFFFFF"/>
-                </a:solidFill>
-                <a:latin typeface="Calibri"/>
-              </a:defRPr>
-            </a:pPr>
-            <a:r>
-              <a:t>Begin Data Infrastructure Planning</a:t>
-            </a:r>
-          </a:p>
-        </p:txBody>
-      </p:sp>
-      <p:sp>
-        <p:nvSpPr>
-          <p:cNvPr id="12" name="TextBox 11"/>
-          <p:cNvSpPr txBox="1"/>
-          <p:nvPr/>
-        </p:nvSpPr>
-        <p:spPr>
-          <a:xfrm>
-            <a:off x="1828800" y="3337560"/>
-            <a:ext cx="8961120" cy="594360"/>
-          </a:xfrm>
-          <a:prstGeom prst="rect">
-            <a:avLst/>
-          </a:prstGeom>
-          <a:noFill/>
-        </p:spPr>
-        <p:txBody>
-          <a:bodyPr wrap="square">
-            <a:spAutoFit/>
-          </a:bodyPr>
-          <a:lstStyle/>
-          <a:p>
-            <a:pPr algn="l">
-              <a:defRPr sz="1200" b="0">
-                <a:solidFill>
-                  <a:srgbClr val="D9DBD8"/>
-                </a:solidFill>
-                <a:latin typeface="Calibri"/>
-              </a:defRPr>
-            </a:pPr>
-            <a:r>
-              <a:t>Initiate requirements for a unified data layer connecting Shopify, support systems, and telemetry data. This is the foundation for forecasting and AXS Intelligence.</a:t>
-            </a:r>
-          </a:p>
-        </p:txBody>
-      </p:sp>
-      <p:sp>
-        <p:nvSpPr>
-          <p:cNvPr id="13" name="Rounded Rectangle 12"/>
-          <p:cNvSpPr/>
-          <p:nvPr/>
-        </p:nvSpPr>
-        <p:spPr>
-          <a:xfrm>
-            <a:off x="731520" y="4297680"/>
-            <a:ext cx="10515600" cy="1234440"/>
-          </a:xfrm>
-          <a:prstGeom prst="roundRect">
-            <a:avLst>
-              <a:gd name="adj" fmla="val 4000"/>
-            </a:avLst>
-          </a:prstGeom>
-          <a:solidFill>
-            <a:srgbClr val="2A2A2C"/>
-          </a:solidFill>
-          <a:ln w="12700">
-            <a:solidFill>
-              <a:srgbClr val="3A3A3C"/>
-            </a:solidFill>
-          </a:ln>
-        </p:spPr>
-        <p:style>
-          <a:lnRef idx="1">
-            <a:schemeClr val="accent1"/>
-          </a:lnRef>
-          <a:fillRef idx="3">
-            <a:schemeClr val="accent1"/>
-          </a:fillRef>
-          <a:effectRef idx="2">
-            <a:schemeClr val="accent1"/>
-          </a:effectRef>
-          <a:fontRef idx="minor">
-            <a:schemeClr val="lt1"/>
-          </a:fontRef>
-        </p:style>
-        <p:txBody>
-          <a:bodyPr rtlCol="0" anchor="ctr"/>
-          <a:lstStyle/>
-          <a:p>
-            <a:pPr algn="ctr"/>
-          </a:p>
-        </p:txBody>
-      </p:sp>
-      <p:sp>
-        <p:nvSpPr>
-          <p:cNvPr id="14" name="Oval 13"/>
-          <p:cNvSpPr/>
-          <p:nvPr/>
-        </p:nvSpPr>
-        <p:spPr>
-          <a:xfrm>
-            <a:off x="1097280" y="4553712"/>
-            <a:ext cx="457200" cy="457200"/>
-          </a:xfrm>
-          <a:prstGeom prst="ellipse">
-            <a:avLst/>
-          </a:prstGeom>
-          <a:solidFill>
-            <a:srgbClr val="E51937"/>
-          </a:solidFill>
-          <a:ln>
-            <a:noFill/>
-          </a:ln>
-        </p:spPr>
-        <p:style>
-          <a:lnRef idx="1">
-            <a:schemeClr val="accent1"/>
-          </a:lnRef>
-          <a:fillRef idx="3">
-            <a:schemeClr val="accent1"/>
-          </a:fillRef>
-          <a:effectRef idx="2">
-            <a:schemeClr val="accent1"/>
-          </a:effectRef>
-          <a:fontRef idx="minor">
-            <a:schemeClr val="lt1"/>
-          </a:fontRef>
-        </p:style>
-        <p:txBody>
-          <a:bodyPr rtlCol="0" anchor="ctr"/>
-          <a:lstStyle/>
-          <a:p>
-            <a:pPr algn="ctr">
-              <a:defRPr sz="1800" b="1">
-                <a:solidFill>
-                  <a:srgbClr val="FFFFFF"/>
-                </a:solidFill>
-              </a:defRPr>
-            </a:pPr>
-            <a:r>
-              <a:t>3</a:t>
-            </a:r>
-          </a:p>
-        </p:txBody>
-      </p:sp>
-      <p:sp>
-        <p:nvSpPr>
-          <p:cNvPr id="15" name="TextBox 14"/>
-          <p:cNvSpPr txBox="1"/>
-          <p:nvPr/>
-        </p:nvSpPr>
-        <p:spPr>
-          <a:xfrm>
-            <a:off x="1828800" y="4407408"/>
-            <a:ext cx="8961120" cy="365760"/>
-          </a:xfrm>
-          <a:prstGeom prst="rect">
-            <a:avLst/>
-          </a:prstGeom>
-          <a:noFill/>
-        </p:spPr>
-        <p:txBody>
-          <a:bodyPr wrap="square">
-            <a:spAutoFit/>
-          </a:bodyPr>
-          <a:lstStyle/>
-          <a:p>
-            <a:pPr algn="l">
-              <a:defRPr sz="1800" b="1">
-                <a:solidFill>
-                  <a:srgbClr val="FFFFFF"/>
-                </a:solidFill>
-                <a:latin typeface="Calibri"/>
-              </a:defRPr>
-            </a:pPr>
-            <a:r>
-              <a:t>Hold Sequencing Discipline</a:t>
-            </a:r>
-          </a:p>
-        </p:txBody>
-      </p:sp>
-      <p:sp>
-        <p:nvSpPr>
-          <p:cNvPr id="16" name="TextBox 15"/>
-          <p:cNvSpPr txBox="1"/>
-          <p:nvPr/>
-        </p:nvSpPr>
-        <p:spPr>
-          <a:xfrm>
-            <a:off x="1828800" y="4800600"/>
-            <a:ext cx="8961120" cy="594360"/>
-          </a:xfrm>
-          <a:prstGeom prst="rect">
-            <a:avLst/>
-          </a:prstGeom>
-          <a:noFill/>
-        </p:spPr>
-        <p:txBody>
-          <a:bodyPr wrap="square">
-            <a:spAutoFit/>
-          </a:bodyPr>
-          <a:lstStyle/>
-          <a:p>
-            <a:pPr algn="l">
-              <a:defRPr sz="1200" b="0">
-                <a:solidFill>
-                  <a:srgbClr val="D9DBD8"/>
-                </a:solidFill>
-                <a:latin typeface="Calibri"/>
-              </a:defRPr>
-            </a:pPr>
-            <a:r>
-              <a:t>Bounded, well-defined problems first. Broader transformation after measured proof. The 90-day pilot produces data to justify or redirect every subsequent investment.</a:t>
-            </a:r>
-          </a:p>
-        </p:txBody>
-      </p:sp>
-      <p:sp>
-        <p:nvSpPr>
-          <p:cNvPr id="17" name="Rounded Rectangle 16"/>
-          <p:cNvSpPr/>
-          <p:nvPr/>
-        </p:nvSpPr>
-        <p:spPr>
-          <a:xfrm>
-            <a:off x="731520" y="5897880"/>
-            <a:ext cx="10515600" cy="365760"/>
-          </a:xfrm>
-          <a:prstGeom prst="roundRect">
-            <a:avLst>
-              <a:gd name="adj" fmla="val 10000"/>
-            </a:avLst>
-          </a:prstGeom>
-          <a:solidFill>
-            <a:srgbClr val="2A2A2C"/>
-          </a:solidFill>
-          <a:ln w="12700">
-            <a:solidFill>
-              <a:srgbClr val="E51937"/>
-            </a:solidFill>
-          </a:ln>
-        </p:spPr>
-        <p:style>
-          <a:lnRef idx="1">
-            <a:schemeClr val="accent1"/>
-          </a:lnRef>
-          <a:fillRef idx="3">
-            <a:schemeClr val="accent1"/>
-          </a:fillRef>
-          <a:effectRef idx="2">
-            <a:schemeClr val="accent1"/>
-          </a:effectRef>
-          <a:fontRef idx="minor">
-            <a:schemeClr val="lt1"/>
-          </a:fontRef>
-        </p:style>
-        <p:txBody>
-          <a:bodyPr rtlCol="0" anchor="ctr"/>
-          <a:lstStyle/>
-          <a:p>
-            <a:pPr algn="ctr"/>
-          </a:p>
-        </p:txBody>
-      </p:sp>
-      <p:sp>
-        <p:nvSpPr>
-          <p:cNvPr id="18" name="TextBox 17"/>
+          <p:cNvPr id="19" name="TextBox 18"/>
           <p:cNvSpPr txBox="1"/>
           <p:nvPr/>
         </p:nvSpPr>
@@ -11709,7 +11838,7 @@
             <a:pPr algn="ctr">
               <a:defRPr sz="1200" b="1">
                 <a:solidFill>
-                  <a:srgbClr val="E51937"/>
+                  <a:srgbClr val="1C1C1E"/>
                 </a:solidFill>
                 <a:latin typeface="Calibri"/>
               </a:defRPr>

</xml_diff>

<commit_message>
Standardize on AWS-native stack and reframe talent strategy
Replace Azure AI Search + OpenAI with Amazon Kendra + Bedrock
across playbook, presentation, executive brief, reference doc,
and prompt file. Replace Vertex AI/Databricks with SageMaker.
SRAM runs on AWS so all AI tooling stays on the same provider.

Rewrite talent section: 250-400 engineers (acquisition-built
from Hammerhead/Quarq) work in Python, TS, React, Svelte, not
firmware-only. AI coding tools mean no new engineering hires
needed even for Phase 4. Bottleneck shifts to product managers
and QA as output scales. Acquisition-era data integration is
the real Phase 2 challenge.

Add gitignore for PowerPoint temp files.
</commit_message>
<xml_diff>
--- a/presentation/SRAM_AI_Adoption_Playbook.pptx
+++ b/presentation/SRAM_AI_Adoption_Playbook.pptx
@@ -4629,7 +4629,7 @@
               </a:defRPr>
             </a:pPr>
             <a:r>
-              <a:t>•  Zendesk AI + Azure AI Search + OpenAI API</a:t>
+              <a:t>•  Zendesk AI + Amazon Kendra + Bedrock</a:t>
             </a:r>
           </a:p>
           <a:p>
@@ -4803,7 +4803,7 @@
               </a:defRPr>
             </a:pPr>
             <a:r>
-              <a:t>•  Data engineering hires (2-3)</a:t>
+              <a:t>•  Add product managers and QA capacity</a:t>
             </a:r>
           </a:p>
           <a:p>
@@ -4835,7 +4835,7 @@
               </a:defRPr>
             </a:pPr>
             <a:r>
-              <a:t>•  Vertex AI or Databricks for forecasting</a:t>
+              <a:t>•  AWS SageMaker for forecasting</a:t>
             </a:r>
           </a:p>
           <a:p>
@@ -11292,7 +11292,7 @@
               </a:defRPr>
             </a:pPr>
             <a:r>
-              <a:t>Azure AI Search</a:t>
+              <a:t>Amazon Kendra</a:t>
             </a:r>
             <a:br/>
             <a:r>
@@ -11510,7 +11510,7 @@
               </a:defRPr>
             </a:pPr>
             <a:r>
-              <a:t>OpenAI generates</a:t>
+              <a:t>Amazon Bedrock</a:t>
             </a:r>
             <a:br/>
             <a:r>

</xml_diff>

<commit_message>
Replace metrics table with five SMART goals
Playbook Section 4 now has five numbered SMART goals with
specific targets, measurement methods, and trigger thresholds
(e.g., below 50% acceptance at day 45 triggers scope review).
Presentation slide 7 updated to match with numbered goal rows.
</commit_message>
<xml_diff>
--- a/presentation/SRAM_AI_Adoption_Playbook.pptx
+++ b/presentation/SRAM_AI_Adoption_Playbook.pptx
@@ -12701,7 +12701,7 @@
               </a:defRPr>
             </a:pPr>
             <a:r>
-              <a:t>90-Day Pilot Targets</a:t>
+              <a:t>SMART Goals (90 Days)</a:t>
             </a:r>
           </a:p>
         </p:txBody>
@@ -12759,22 +12759,58 @@
         </p:nvSpPr>
         <p:spPr>
           <a:xfrm>
-            <a:off x="914400" y="1737360"/>
-            <a:ext cx="2926080" cy="274320"/>
-          </a:xfrm>
-          <a:prstGeom prst="rect">
-            <a:avLst/>
-          </a:prstGeom>
-          <a:noFill/>
-        </p:spPr>
-        <p:txBody>
-          <a:bodyPr wrap="square">
-            <a:spAutoFit/>
-          </a:bodyPr>
-          <a:lstStyle/>
-          <a:p>
-            <a:pPr algn="l">
-              <a:defRPr sz="1200" b="0" i="0">
+            <a:off x="822960" y="1737360"/>
+            <a:ext cx="228600" cy="274320"/>
+          </a:xfrm>
+          <a:prstGeom prst="rect">
+            <a:avLst/>
+          </a:prstGeom>
+          <a:noFill/>
+        </p:spPr>
+        <p:txBody>
+          <a:bodyPr wrap="square">
+            <a:spAutoFit/>
+          </a:bodyPr>
+          <a:lstStyle/>
+          <a:p>
+            <a:pPr algn="l">
+              <a:defRPr sz="1100" b="1" i="0">
+                <a:solidFill>
+                  <a:srgbClr val="767676"/>
+                </a:solidFill>
+                <a:latin typeface="Calibri"/>
+              </a:defRPr>
+            </a:pPr>
+            <a:r>
+              <a:t>1</a:t>
+            </a:r>
+          </a:p>
+        </p:txBody>
+      </p:sp>
+      <p:sp>
+        <p:nvSpPr>
+          <p:cNvPr id="8" name="TextBox 7"/>
+          <p:cNvSpPr txBox="1"/>
+          <p:nvPr/>
+        </p:nvSpPr>
+        <p:spPr>
+          <a:xfrm>
+            <a:off x="1051560" y="1737360"/>
+            <a:ext cx="2103120" cy="274320"/>
+          </a:xfrm>
+          <a:prstGeom prst="rect">
+            <a:avLst/>
+          </a:prstGeom>
+          <a:noFill/>
+        </p:spPr>
+        <p:txBody>
+          <a:bodyPr wrap="square">
+            <a:spAutoFit/>
+          </a:bodyPr>
+          <a:lstStyle/>
+          <a:p>
+            <a:pPr algn="l">
+              <a:defRPr sz="1100" b="0" i="0">
                 <a:solidFill>
                   <a:srgbClr val="3A3A3C"/>
                 </a:solidFill>
@@ -12782,35 +12818,35 @@
               </a:defRPr>
             </a:pPr>
             <a:r>
-              <a:t>Time-to-first-response</a:t>
-            </a:r>
-          </a:p>
-        </p:txBody>
-      </p:sp>
-      <p:sp>
-        <p:nvSpPr>
-          <p:cNvPr id="8" name="TextBox 7"/>
-          <p:cNvSpPr txBox="1"/>
-          <p:nvPr/>
-        </p:nvSpPr>
-        <p:spPr>
-          <a:xfrm>
-            <a:off x="4023360" y="1737360"/>
-            <a:ext cx="1645920" cy="274320"/>
-          </a:xfrm>
-          <a:prstGeom prst="rect">
-            <a:avLst/>
-          </a:prstGeom>
-          <a:noFill/>
-        </p:spPr>
-        <p:txBody>
-          <a:bodyPr wrap="square">
-            <a:spAutoFit/>
-          </a:bodyPr>
-          <a:lstStyle/>
-          <a:p>
-            <a:pPr algn="l">
-              <a:defRPr sz="1200" b="1" i="0">
+              <a:t>First-response time</a:t>
+            </a:r>
+          </a:p>
+        </p:txBody>
+      </p:sp>
+      <p:sp>
+        <p:nvSpPr>
+          <p:cNvPr id="9" name="TextBox 8"/>
+          <p:cNvSpPr txBox="1"/>
+          <p:nvPr/>
+        </p:nvSpPr>
+        <p:spPr>
+          <a:xfrm>
+            <a:off x="3200400" y="1737360"/>
+            <a:ext cx="914400" cy="274320"/>
+          </a:xfrm>
+          <a:prstGeom prst="rect">
+            <a:avLst/>
+          </a:prstGeom>
+          <a:noFill/>
+        </p:spPr>
+        <p:txBody>
+          <a:bodyPr wrap="square">
+            <a:spAutoFit/>
+          </a:bodyPr>
+          <a:lstStyle/>
+          <a:p>
+            <a:pPr algn="l">
+              <a:defRPr sz="1100" b="1" i="0">
                 <a:solidFill>
                   <a:srgbClr val="1C1C1E"/>
                 </a:solidFill>
@@ -12818,35 +12854,107 @@
               </a:defRPr>
             </a:pPr>
             <a:r>
-              <a:t>40% reduction</a:t>
-            </a:r>
-          </a:p>
-        </p:txBody>
-      </p:sp>
-      <p:sp>
-        <p:nvSpPr>
-          <p:cNvPr id="9" name="TextBox 8"/>
-          <p:cNvSpPr txBox="1"/>
-          <p:nvPr/>
-        </p:nvSpPr>
-        <p:spPr>
-          <a:xfrm>
-            <a:off x="914400" y="2121408"/>
-            <a:ext cx="2926080" cy="274320"/>
-          </a:xfrm>
-          <a:prstGeom prst="rect">
-            <a:avLst/>
-          </a:prstGeom>
-          <a:noFill/>
-        </p:spPr>
-        <p:txBody>
-          <a:bodyPr wrap="square">
-            <a:spAutoFit/>
-          </a:bodyPr>
-          <a:lstStyle/>
-          <a:p>
-            <a:pPr algn="l">
-              <a:defRPr sz="1200" b="0" i="0">
+              <a:t>-40%</a:t>
+            </a:r>
+          </a:p>
+        </p:txBody>
+      </p:sp>
+      <p:sp>
+        <p:nvSpPr>
+          <p:cNvPr id="10" name="TextBox 9"/>
+          <p:cNvSpPr txBox="1"/>
+          <p:nvPr/>
+        </p:nvSpPr>
+        <p:spPr>
+          <a:xfrm>
+            <a:off x="4114800" y="1737360"/>
+            <a:ext cx="1554480" cy="274320"/>
+          </a:xfrm>
+          <a:prstGeom prst="rect">
+            <a:avLst/>
+          </a:prstGeom>
+          <a:noFill/>
+        </p:spPr>
+        <p:txBody>
+          <a:bodyPr wrap="square">
+            <a:spAutoFit/>
+          </a:bodyPr>
+          <a:lstStyle/>
+          <a:p>
+            <a:pPr algn="l">
+              <a:defRPr sz="900" b="0" i="0">
+                <a:solidFill>
+                  <a:srgbClr val="767676"/>
+                </a:solidFill>
+                <a:latin typeface="Calibri"/>
+              </a:defRPr>
+            </a:pPr>
+            <a:r>
+              <a:t>vs. current SLA</a:t>
+            </a:r>
+          </a:p>
+        </p:txBody>
+      </p:sp>
+      <p:sp>
+        <p:nvSpPr>
+          <p:cNvPr id="11" name="TextBox 10"/>
+          <p:cNvSpPr txBox="1"/>
+          <p:nvPr/>
+        </p:nvSpPr>
+        <p:spPr>
+          <a:xfrm>
+            <a:off x="822960" y="2121408"/>
+            <a:ext cx="228600" cy="274320"/>
+          </a:xfrm>
+          <a:prstGeom prst="rect">
+            <a:avLst/>
+          </a:prstGeom>
+          <a:noFill/>
+        </p:spPr>
+        <p:txBody>
+          <a:bodyPr wrap="square">
+            <a:spAutoFit/>
+          </a:bodyPr>
+          <a:lstStyle/>
+          <a:p>
+            <a:pPr algn="l">
+              <a:defRPr sz="1100" b="1" i="0">
+                <a:solidFill>
+                  <a:srgbClr val="767676"/>
+                </a:solidFill>
+                <a:latin typeface="Calibri"/>
+              </a:defRPr>
+            </a:pPr>
+            <a:r>
+              <a:t>2</a:t>
+            </a:r>
+          </a:p>
+        </p:txBody>
+      </p:sp>
+      <p:sp>
+        <p:nvSpPr>
+          <p:cNvPr id="12" name="TextBox 11"/>
+          <p:cNvSpPr txBox="1"/>
+          <p:nvPr/>
+        </p:nvSpPr>
+        <p:spPr>
+          <a:xfrm>
+            <a:off x="1051560" y="2121408"/>
+            <a:ext cx="2103120" cy="274320"/>
+          </a:xfrm>
+          <a:prstGeom prst="rect">
+            <a:avLst/>
+          </a:prstGeom>
+          <a:noFill/>
+        </p:spPr>
+        <p:txBody>
+          <a:bodyPr wrap="square">
+            <a:spAutoFit/>
+          </a:bodyPr>
+          <a:lstStyle/>
+          <a:p>
+            <a:pPr algn="l">
+              <a:defRPr sz="1100" b="0" i="0">
                 <a:solidFill>
                   <a:srgbClr val="3A3A3C"/>
                 </a:solidFill>
@@ -12861,28 +12969,28 @@
       </p:sp>
       <p:sp>
         <p:nvSpPr>
-          <p:cNvPr id="10" name="TextBox 9"/>
-          <p:cNvSpPr txBox="1"/>
-          <p:nvPr/>
-        </p:nvSpPr>
-        <p:spPr>
-          <a:xfrm>
-            <a:off x="4023360" y="2121408"/>
-            <a:ext cx="1645920" cy="274320"/>
-          </a:xfrm>
-          <a:prstGeom prst="rect">
-            <a:avLst/>
-          </a:prstGeom>
-          <a:noFill/>
-        </p:spPr>
-        <p:txBody>
-          <a:bodyPr wrap="square">
-            <a:spAutoFit/>
-          </a:bodyPr>
-          <a:lstStyle/>
-          <a:p>
-            <a:pPr algn="l">
-              <a:defRPr sz="1200" b="1" i="0">
+          <p:cNvPr id="13" name="TextBox 12"/>
+          <p:cNvSpPr txBox="1"/>
+          <p:nvPr/>
+        </p:nvSpPr>
+        <p:spPr>
+          <a:xfrm>
+            <a:off x="3200400" y="2121408"/>
+            <a:ext cx="914400" cy="274320"/>
+          </a:xfrm>
+          <a:prstGeom prst="rect">
+            <a:avLst/>
+          </a:prstGeom>
+          <a:noFill/>
+        </p:spPr>
+        <p:txBody>
+          <a:bodyPr wrap="square">
+            <a:spAutoFit/>
+          </a:bodyPr>
+          <a:lstStyle/>
+          <a:p>
+            <a:pPr algn="l">
+              <a:defRPr sz="1100" b="1" i="0">
                 <a:solidFill>
                   <a:srgbClr val="1C1C1E"/>
                 </a:solidFill>
@@ -12890,14 +12998,50 @@
               </a:defRPr>
             </a:pPr>
             <a:r>
-              <a:t>15% improvement</a:t>
-            </a:r>
-          </a:p>
-        </p:txBody>
-      </p:sp>
-      <p:sp>
-        <p:nvSpPr>
-          <p:cNvPr id="11" name="Rounded Rectangle 10"/>
+              <a:t>+15 pts</a:t>
+            </a:r>
+          </a:p>
+        </p:txBody>
+      </p:sp>
+      <p:sp>
+        <p:nvSpPr>
+          <p:cNvPr id="14" name="TextBox 13"/>
+          <p:cNvSpPr txBox="1"/>
+          <p:nvPr/>
+        </p:nvSpPr>
+        <p:spPr>
+          <a:xfrm>
+            <a:off x="4114800" y="2121408"/>
+            <a:ext cx="1554480" cy="274320"/>
+          </a:xfrm>
+          <a:prstGeom prst="rect">
+            <a:avLst/>
+          </a:prstGeom>
+          <a:noFill/>
+        </p:spPr>
+        <p:txBody>
+          <a:bodyPr wrap="square">
+            <a:spAutoFit/>
+          </a:bodyPr>
+          <a:lstStyle/>
+          <a:p>
+            <a:pPr algn="l">
+              <a:defRPr sz="900" b="0" i="0">
+                <a:solidFill>
+                  <a:srgbClr val="767676"/>
+                </a:solidFill>
+                <a:latin typeface="Calibri"/>
+              </a:defRPr>
+            </a:pPr>
+            <a:r>
+              <a:t>vs. current rate</a:t>
+            </a:r>
+          </a:p>
+        </p:txBody>
+      </p:sp>
+      <p:sp>
+        <p:nvSpPr>
+          <p:cNvPr id="15" name="Rounded Rectangle 14"/>
           <p:cNvSpPr/>
           <p:nvPr/>
         </p:nvSpPr>
@@ -12942,28 +13086,64 @@
       </p:sp>
       <p:sp>
         <p:nvSpPr>
-          <p:cNvPr id="12" name="TextBox 11"/>
-          <p:cNvSpPr txBox="1"/>
-          <p:nvPr/>
-        </p:nvSpPr>
-        <p:spPr>
-          <a:xfrm>
-            <a:off x="914400" y="2505456"/>
-            <a:ext cx="2926080" cy="274320"/>
-          </a:xfrm>
-          <a:prstGeom prst="rect">
-            <a:avLst/>
-          </a:prstGeom>
-          <a:noFill/>
-        </p:spPr>
-        <p:txBody>
-          <a:bodyPr wrap="square">
-            <a:spAutoFit/>
-          </a:bodyPr>
-          <a:lstStyle/>
-          <a:p>
-            <a:pPr algn="l">
-              <a:defRPr sz="1200" b="0" i="0">
+          <p:cNvPr id="16" name="TextBox 15"/>
+          <p:cNvSpPr txBox="1"/>
+          <p:nvPr/>
+        </p:nvSpPr>
+        <p:spPr>
+          <a:xfrm>
+            <a:off x="822960" y="2505456"/>
+            <a:ext cx="228600" cy="274320"/>
+          </a:xfrm>
+          <a:prstGeom prst="rect">
+            <a:avLst/>
+          </a:prstGeom>
+          <a:noFill/>
+        </p:spPr>
+        <p:txBody>
+          <a:bodyPr wrap="square">
+            <a:spAutoFit/>
+          </a:bodyPr>
+          <a:lstStyle/>
+          <a:p>
+            <a:pPr algn="l">
+              <a:defRPr sz="1100" b="1" i="0">
+                <a:solidFill>
+                  <a:srgbClr val="767676"/>
+                </a:solidFill>
+                <a:latin typeface="Calibri"/>
+              </a:defRPr>
+            </a:pPr>
+            <a:r>
+              <a:t>3</a:t>
+            </a:r>
+          </a:p>
+        </p:txBody>
+      </p:sp>
+      <p:sp>
+        <p:nvSpPr>
+          <p:cNvPr id="17" name="TextBox 16"/>
+          <p:cNvSpPr txBox="1"/>
+          <p:nvPr/>
+        </p:nvSpPr>
+        <p:spPr>
+          <a:xfrm>
+            <a:off x="1051560" y="2505456"/>
+            <a:ext cx="2103120" cy="274320"/>
+          </a:xfrm>
+          <a:prstGeom prst="rect">
+            <a:avLst/>
+          </a:prstGeom>
+          <a:noFill/>
+        </p:spPr>
+        <p:txBody>
+          <a:bodyPr wrap="square">
+            <a:spAutoFit/>
+          </a:bodyPr>
+          <a:lstStyle/>
+          <a:p>
+            <a:pPr algn="l">
+              <a:defRPr sz="1100" b="0" i="0">
                 <a:solidFill>
                   <a:srgbClr val="3A3A3C"/>
                 </a:solidFill>
@@ -12971,35 +13151,35 @@
               </a:defRPr>
             </a:pPr>
             <a:r>
-              <a:t>Agent productivity</a:t>
-            </a:r>
-          </a:p>
-        </p:txBody>
-      </p:sp>
-      <p:sp>
-        <p:nvSpPr>
-          <p:cNvPr id="13" name="TextBox 12"/>
-          <p:cNvSpPr txBox="1"/>
-          <p:nvPr/>
-        </p:nvSpPr>
-        <p:spPr>
-          <a:xfrm>
-            <a:off x="4023360" y="2505456"/>
-            <a:ext cx="1645920" cy="274320"/>
-          </a:xfrm>
-          <a:prstGeom prst="rect">
-            <a:avLst/>
-          </a:prstGeom>
-          <a:noFill/>
-        </p:spPr>
-        <p:txBody>
-          <a:bodyPr wrap="square">
-            <a:spAutoFit/>
-          </a:bodyPr>
-          <a:lstStyle/>
-          <a:p>
-            <a:pPr algn="l">
-              <a:defRPr sz="1200" b="1" i="0">
+              <a:t>AI draft acceptance</a:t>
+            </a:r>
+          </a:p>
+        </p:txBody>
+      </p:sp>
+      <p:sp>
+        <p:nvSpPr>
+          <p:cNvPr id="18" name="TextBox 17"/>
+          <p:cNvSpPr txBox="1"/>
+          <p:nvPr/>
+        </p:nvSpPr>
+        <p:spPr>
+          <a:xfrm>
+            <a:off x="3200400" y="2505456"/>
+            <a:ext cx="914400" cy="274320"/>
+          </a:xfrm>
+          <a:prstGeom prst="rect">
+            <a:avLst/>
+          </a:prstGeom>
+          <a:noFill/>
+        </p:spPr>
+        <p:txBody>
+          <a:bodyPr wrap="square">
+            <a:spAutoFit/>
+          </a:bodyPr>
+          <a:lstStyle/>
+          <a:p>
+            <a:pPr algn="l">
+              <a:defRPr sz="1100" b="1" i="0">
                 <a:solidFill>
                   <a:srgbClr val="1C1C1E"/>
                 </a:solidFill>
@@ -13007,35 +13187,107 @@
               </a:defRPr>
             </a:pPr>
             <a:r>
-              <a:t>25% increase</a:t>
-            </a:r>
-          </a:p>
-        </p:txBody>
-      </p:sp>
-      <p:sp>
-        <p:nvSpPr>
-          <p:cNvPr id="14" name="TextBox 13"/>
-          <p:cNvSpPr txBox="1"/>
-          <p:nvPr/>
-        </p:nvSpPr>
-        <p:spPr>
-          <a:xfrm>
-            <a:off x="914400" y="2889504"/>
-            <a:ext cx="2926080" cy="274320"/>
-          </a:xfrm>
-          <a:prstGeom prst="rect">
-            <a:avLst/>
-          </a:prstGeom>
-          <a:noFill/>
-        </p:spPr>
-        <p:txBody>
-          <a:bodyPr wrap="square">
-            <a:spAutoFit/>
-          </a:bodyPr>
-          <a:lstStyle/>
-          <a:p>
-            <a:pPr algn="l">
-              <a:defRPr sz="1200" b="0" i="0">
+              <a:t>&gt;70%</a:t>
+            </a:r>
+          </a:p>
+        </p:txBody>
+      </p:sp>
+      <p:sp>
+        <p:nvSpPr>
+          <p:cNvPr id="19" name="TextBox 18"/>
+          <p:cNvSpPr txBox="1"/>
+          <p:nvPr/>
+        </p:nvSpPr>
+        <p:spPr>
+          <a:xfrm>
+            <a:off x="4114800" y="2505456"/>
+            <a:ext cx="1554480" cy="274320"/>
+          </a:xfrm>
+          <a:prstGeom prst="rect">
+            <a:avLst/>
+          </a:prstGeom>
+          <a:noFill/>
+        </p:spPr>
+        <p:txBody>
+          <a:bodyPr wrap="square">
+            <a:spAutoFit/>
+          </a:bodyPr>
+          <a:lstStyle/>
+          <a:p>
+            <a:pPr algn="l">
+              <a:defRPr sz="900" b="0" i="0">
+                <a:solidFill>
+                  <a:srgbClr val="767676"/>
+                </a:solidFill>
+                <a:latin typeface="Calibri"/>
+              </a:defRPr>
+            </a:pPr>
+            <a:r>
+              <a:t>agents approve draft</a:t>
+            </a:r>
+          </a:p>
+        </p:txBody>
+      </p:sp>
+      <p:sp>
+        <p:nvSpPr>
+          <p:cNvPr id="20" name="TextBox 19"/>
+          <p:cNvSpPr txBox="1"/>
+          <p:nvPr/>
+        </p:nvSpPr>
+        <p:spPr>
+          <a:xfrm>
+            <a:off x="822960" y="2889504"/>
+            <a:ext cx="228600" cy="274320"/>
+          </a:xfrm>
+          <a:prstGeom prst="rect">
+            <a:avLst/>
+          </a:prstGeom>
+          <a:noFill/>
+        </p:spPr>
+        <p:txBody>
+          <a:bodyPr wrap="square">
+            <a:spAutoFit/>
+          </a:bodyPr>
+          <a:lstStyle/>
+          <a:p>
+            <a:pPr algn="l">
+              <a:defRPr sz="1100" b="1" i="0">
+                <a:solidFill>
+                  <a:srgbClr val="767676"/>
+                </a:solidFill>
+                <a:latin typeface="Calibri"/>
+              </a:defRPr>
+            </a:pPr>
+            <a:r>
+              <a:t>4</a:t>
+            </a:r>
+          </a:p>
+        </p:txBody>
+      </p:sp>
+      <p:sp>
+        <p:nvSpPr>
+          <p:cNvPr id="21" name="TextBox 20"/>
+          <p:cNvSpPr txBox="1"/>
+          <p:nvPr/>
+        </p:nvSpPr>
+        <p:spPr>
+          <a:xfrm>
+            <a:off x="1051560" y="2889504"/>
+            <a:ext cx="2103120" cy="274320"/>
+          </a:xfrm>
+          <a:prstGeom prst="rect">
+            <a:avLst/>
+          </a:prstGeom>
+          <a:noFill/>
+        </p:spPr>
+        <p:txBody>
+          <a:bodyPr wrap="square">
+            <a:spAutoFit/>
+          </a:bodyPr>
+          <a:lstStyle/>
+          <a:p>
+            <a:pPr algn="l">
+              <a:defRPr sz="1100" b="0" i="0">
                 <a:solidFill>
                   <a:srgbClr val="3A3A3C"/>
                 </a:solidFill>
@@ -13043,35 +13295,35 @@
               </a:defRPr>
             </a:pPr>
             <a:r>
-              <a:t>AI draft acceptance rate</a:t>
-            </a:r>
-          </a:p>
-        </p:txBody>
-      </p:sp>
-      <p:sp>
-        <p:nvSpPr>
-          <p:cNvPr id="15" name="TextBox 14"/>
-          <p:cNvSpPr txBox="1"/>
-          <p:nvPr/>
-        </p:nvSpPr>
-        <p:spPr>
-          <a:xfrm>
-            <a:off x="4023360" y="2889504"/>
-            <a:ext cx="1645920" cy="274320"/>
-          </a:xfrm>
-          <a:prstGeom prst="rect">
-            <a:avLst/>
-          </a:prstGeom>
-          <a:noFill/>
-        </p:spPr>
-        <p:txBody>
-          <a:bodyPr wrap="square">
-            <a:spAutoFit/>
-          </a:bodyPr>
-          <a:lstStyle/>
-          <a:p>
-            <a:pPr algn="l">
-              <a:defRPr sz="1200" b="1" i="0">
+              <a:t>Agent throughput</a:t>
+            </a:r>
+          </a:p>
+        </p:txBody>
+      </p:sp>
+      <p:sp>
+        <p:nvSpPr>
+          <p:cNvPr id="22" name="TextBox 21"/>
+          <p:cNvSpPr txBox="1"/>
+          <p:nvPr/>
+        </p:nvSpPr>
+        <p:spPr>
+          <a:xfrm>
+            <a:off x="3200400" y="2889504"/>
+            <a:ext cx="914400" cy="274320"/>
+          </a:xfrm>
+          <a:prstGeom prst="rect">
+            <a:avLst/>
+          </a:prstGeom>
+          <a:noFill/>
+        </p:spPr>
+        <p:txBody>
+          <a:bodyPr wrap="square">
+            <a:spAutoFit/>
+          </a:bodyPr>
+          <a:lstStyle/>
+          <a:p>
+            <a:pPr algn="l">
+              <a:defRPr sz="1100" b="1" i="0">
                 <a:solidFill>
                   <a:srgbClr val="1C1C1E"/>
                 </a:solidFill>
@@ -13079,14 +13331,50 @@
               </a:defRPr>
             </a:pPr>
             <a:r>
-              <a:t>Above 70%</a:t>
-            </a:r>
-          </a:p>
-        </p:txBody>
-      </p:sp>
-      <p:sp>
-        <p:nvSpPr>
-          <p:cNvPr id="16" name="Rounded Rectangle 15"/>
+              <a:t>+25%</a:t>
+            </a:r>
+          </a:p>
+        </p:txBody>
+      </p:sp>
+      <p:sp>
+        <p:nvSpPr>
+          <p:cNvPr id="23" name="TextBox 22"/>
+          <p:cNvSpPr txBox="1"/>
+          <p:nvPr/>
+        </p:nvSpPr>
+        <p:spPr>
+          <a:xfrm>
+            <a:off x="4114800" y="2889504"/>
+            <a:ext cx="1554480" cy="274320"/>
+          </a:xfrm>
+          <a:prstGeom prst="rect">
+            <a:avLst/>
+          </a:prstGeom>
+          <a:noFill/>
+        </p:spPr>
+        <p:txBody>
+          <a:bodyPr wrap="square">
+            <a:spAutoFit/>
+          </a:bodyPr>
+          <a:lstStyle/>
+          <a:p>
+            <a:pPr algn="l">
+              <a:defRPr sz="900" b="0" i="0">
+                <a:solidFill>
+                  <a:srgbClr val="767676"/>
+                </a:solidFill>
+                <a:latin typeface="Calibri"/>
+              </a:defRPr>
+            </a:pPr>
+            <a:r>
+              <a:t>tickets per agent/day</a:t>
+            </a:r>
+          </a:p>
+        </p:txBody>
+      </p:sp>
+      <p:sp>
+        <p:nvSpPr>
+          <p:cNvPr id="24" name="Rounded Rectangle 23"/>
           <p:cNvSpPr/>
           <p:nvPr/>
         </p:nvSpPr>
@@ -13131,28 +13419,64 @@
       </p:sp>
       <p:sp>
         <p:nvSpPr>
-          <p:cNvPr id="17" name="TextBox 16"/>
-          <p:cNvSpPr txBox="1"/>
-          <p:nvPr/>
-        </p:nvSpPr>
-        <p:spPr>
-          <a:xfrm>
-            <a:off x="914400" y="3273552"/>
-            <a:ext cx="2926080" cy="274320"/>
-          </a:xfrm>
-          <a:prstGeom prst="rect">
-            <a:avLst/>
-          </a:prstGeom>
-          <a:noFill/>
-        </p:spPr>
-        <p:txBody>
-          <a:bodyPr wrap="square">
-            <a:spAutoFit/>
-          </a:bodyPr>
-          <a:lstStyle/>
-          <a:p>
-            <a:pPr algn="l">
-              <a:defRPr sz="1200" b="0" i="0">
+          <p:cNvPr id="25" name="TextBox 24"/>
+          <p:cNvSpPr txBox="1"/>
+          <p:nvPr/>
+        </p:nvSpPr>
+        <p:spPr>
+          <a:xfrm>
+            <a:off x="822960" y="3273552"/>
+            <a:ext cx="228600" cy="274320"/>
+          </a:xfrm>
+          <a:prstGeom prst="rect">
+            <a:avLst/>
+          </a:prstGeom>
+          <a:noFill/>
+        </p:spPr>
+        <p:txBody>
+          <a:bodyPr wrap="square">
+            <a:spAutoFit/>
+          </a:bodyPr>
+          <a:lstStyle/>
+          <a:p>
+            <a:pPr algn="l">
+              <a:defRPr sz="1100" b="1" i="0">
+                <a:solidFill>
+                  <a:srgbClr val="767676"/>
+                </a:solidFill>
+                <a:latin typeface="Calibri"/>
+              </a:defRPr>
+            </a:pPr>
+            <a:r>
+              <a:t>5</a:t>
+            </a:r>
+          </a:p>
+        </p:txBody>
+      </p:sp>
+      <p:sp>
+        <p:nvSpPr>
+          <p:cNvPr id="26" name="TextBox 25"/>
+          <p:cNvSpPr txBox="1"/>
+          <p:nvPr/>
+        </p:nvSpPr>
+        <p:spPr>
+          <a:xfrm>
+            <a:off x="1051560" y="3273552"/>
+            <a:ext cx="2103120" cy="274320"/>
+          </a:xfrm>
+          <a:prstGeom prst="rect">
+            <a:avLst/>
+          </a:prstGeom>
+          <a:noFill/>
+        </p:spPr>
+        <p:txBody>
+          <a:bodyPr wrap="square">
+            <a:spAutoFit/>
+          </a:bodyPr>
+          <a:lstStyle/>
+          <a:p>
+            <a:pPr algn="l">
+              <a:defRPr sz="1100" b="0" i="0">
                 <a:solidFill>
                   <a:srgbClr val="3A3A3C"/>
                 </a:solidFill>
@@ -13167,28 +13491,28 @@
       </p:sp>
       <p:sp>
         <p:nvSpPr>
-          <p:cNvPr id="18" name="TextBox 17"/>
-          <p:cNvSpPr txBox="1"/>
-          <p:nvPr/>
-        </p:nvSpPr>
-        <p:spPr>
-          <a:xfrm>
-            <a:off x="4023360" y="3273552"/>
-            <a:ext cx="1645920" cy="274320"/>
-          </a:xfrm>
-          <a:prstGeom prst="rect">
-            <a:avLst/>
-          </a:prstGeom>
-          <a:noFill/>
-        </p:spPr>
-        <p:txBody>
-          <a:bodyPr wrap="square">
-            <a:spAutoFit/>
-          </a:bodyPr>
-          <a:lstStyle/>
-          <a:p>
-            <a:pPr algn="l">
-              <a:defRPr sz="1200" b="1" i="0">
+          <p:cNvPr id="27" name="TextBox 26"/>
+          <p:cNvSpPr txBox="1"/>
+          <p:nvPr/>
+        </p:nvSpPr>
+        <p:spPr>
+          <a:xfrm>
+            <a:off x="3200400" y="3273552"/>
+            <a:ext cx="914400" cy="274320"/>
+          </a:xfrm>
+          <a:prstGeom prst="rect">
+            <a:avLst/>
+          </a:prstGeom>
+          <a:noFill/>
+        </p:spPr>
+        <p:txBody>
+          <a:bodyPr wrap="square">
+            <a:spAutoFit/>
+          </a:bodyPr>
+          <a:lstStyle/>
+          <a:p>
+            <a:pPr algn="l">
+              <a:defRPr sz="1100" b="1" i="0">
                 <a:solidFill>
                   <a:srgbClr val="1C1C1E"/>
                 </a:solidFill>
@@ -13203,13 +13527,49 @@
       </p:sp>
       <p:sp>
         <p:nvSpPr>
-          <p:cNvPr id="19" name="TextBox 18"/>
-          <p:cNvSpPr txBox="1"/>
-          <p:nvPr/>
-        </p:nvSpPr>
-        <p:spPr>
-          <a:xfrm>
-            <a:off x="731520" y="3840480"/>
+          <p:cNvPr id="28" name="TextBox 27"/>
+          <p:cNvSpPr txBox="1"/>
+          <p:nvPr/>
+        </p:nvSpPr>
+        <p:spPr>
+          <a:xfrm>
+            <a:off x="4114800" y="3273552"/>
+            <a:ext cx="1554480" cy="274320"/>
+          </a:xfrm>
+          <a:prstGeom prst="rect">
+            <a:avLst/>
+          </a:prstGeom>
+          <a:noFill/>
+        </p:spPr>
+        <p:txBody>
+          <a:bodyPr wrap="square">
+            <a:spAutoFit/>
+          </a:bodyPr>
+          <a:lstStyle/>
+          <a:p>
+            <a:pPr algn="l">
+              <a:defRPr sz="900" b="0" i="0">
+                <a:solidFill>
+                  <a:srgbClr val="767676"/>
+                </a:solidFill>
+                <a:latin typeface="Calibri"/>
+              </a:defRPr>
+            </a:pPr>
+            <a:r>
+              <a:t>CSAT holds flat</a:t>
+            </a:r>
+          </a:p>
+        </p:txBody>
+      </p:sp>
+      <p:sp>
+        <p:nvSpPr>
+          <p:cNvPr id="29" name="TextBox 28"/>
+          <p:cNvSpPr txBox="1"/>
+          <p:nvPr/>
+        </p:nvSpPr>
+        <p:spPr>
+          <a:xfrm>
+            <a:off x="731520" y="3749039"/>
             <a:ext cx="5029200" cy="274320"/>
           </a:xfrm>
           <a:prstGeom prst="rect">
@@ -13239,13 +13599,13 @@
       </p:sp>
       <p:sp>
         <p:nvSpPr>
-          <p:cNvPr id="20" name="TextBox 19"/>
-          <p:cNvSpPr txBox="1"/>
-          <p:nvPr/>
-        </p:nvSpPr>
-        <p:spPr>
-          <a:xfrm>
-            <a:off x="731520" y="4160520"/>
+          <p:cNvPr id="30" name="TextBox 29"/>
+          <p:cNvSpPr txBox="1"/>
+          <p:nvPr/>
+        </p:nvSpPr>
+        <p:spPr>
+          <a:xfrm>
+            <a:off x="731520" y="4069080"/>
             <a:ext cx="5029200" cy="822960"/>
           </a:xfrm>
           <a:prstGeom prst="rect">
@@ -13287,13 +13647,13 @@
       </p:sp>
       <p:sp>
         <p:nvSpPr>
-          <p:cNvPr id="21" name="TextBox 20"/>
-          <p:cNvSpPr txBox="1"/>
-          <p:nvPr/>
-        </p:nvSpPr>
-        <p:spPr>
-          <a:xfrm>
-            <a:off x="731520" y="5166360"/>
+          <p:cNvPr id="31" name="TextBox 30"/>
+          <p:cNvSpPr txBox="1"/>
+          <p:nvPr/>
+        </p:nvSpPr>
+        <p:spPr>
+          <a:xfrm>
+            <a:off x="731520" y="5074920"/>
             <a:ext cx="5029200" cy="274320"/>
           </a:xfrm>
           <a:prstGeom prst="rect">
@@ -13323,13 +13683,13 @@
       </p:sp>
       <p:sp>
         <p:nvSpPr>
-          <p:cNvPr id="22" name="TextBox 21"/>
-          <p:cNvSpPr txBox="1"/>
-          <p:nvPr/>
-        </p:nvSpPr>
-        <p:spPr>
-          <a:xfrm>
-            <a:off x="914400" y="5486400"/>
+          <p:cNvPr id="32" name="TextBox 31"/>
+          <p:cNvSpPr txBox="1"/>
+          <p:nvPr/>
+        </p:nvSpPr>
+        <p:spPr>
+          <a:xfrm>
+            <a:off x="914400" y="5394960"/>
             <a:ext cx="1371600" cy="274320"/>
           </a:xfrm>
           <a:prstGeom prst="rect">
@@ -13359,13 +13719,13 @@
       </p:sp>
       <p:sp>
         <p:nvSpPr>
-          <p:cNvPr id="23" name="TextBox 22"/>
-          <p:cNvSpPr txBox="1"/>
-          <p:nvPr/>
-        </p:nvSpPr>
-        <p:spPr>
-          <a:xfrm>
-            <a:off x="2286000" y="5486400"/>
+          <p:cNvPr id="33" name="TextBox 32"/>
+          <p:cNvSpPr txBox="1"/>
+          <p:nvPr/>
+        </p:nvSpPr>
+        <p:spPr>
+          <a:xfrm>
+            <a:off x="2286000" y="5394960"/>
             <a:ext cx="1371600" cy="274320"/>
           </a:xfrm>
           <a:prstGeom prst="rect">
@@ -13395,13 +13755,13 @@
       </p:sp>
       <p:sp>
         <p:nvSpPr>
-          <p:cNvPr id="24" name="TextBox 23"/>
-          <p:cNvSpPr txBox="1"/>
-          <p:nvPr/>
-        </p:nvSpPr>
-        <p:spPr>
-          <a:xfrm>
-            <a:off x="3657600" y="5486400"/>
+          <p:cNvPr id="34" name="TextBox 33"/>
+          <p:cNvSpPr txBox="1"/>
+          <p:nvPr/>
+        </p:nvSpPr>
+        <p:spPr>
+          <a:xfrm>
+            <a:off x="3657600" y="5394960"/>
             <a:ext cx="914400" cy="274320"/>
           </a:xfrm>
           <a:prstGeom prst="rect">
@@ -13431,13 +13791,13 @@
       </p:sp>
       <p:sp>
         <p:nvSpPr>
-          <p:cNvPr id="25" name="TextBox 24"/>
-          <p:cNvSpPr txBox="1"/>
-          <p:nvPr/>
-        </p:nvSpPr>
-        <p:spPr>
-          <a:xfrm>
-            <a:off x="914400" y="5806440"/>
+          <p:cNvPr id="35" name="TextBox 34"/>
+          <p:cNvSpPr txBox="1"/>
+          <p:nvPr/>
+        </p:nvSpPr>
+        <p:spPr>
+          <a:xfrm>
+            <a:off x="914400" y="5715000"/>
             <a:ext cx="1371600" cy="274320"/>
           </a:xfrm>
           <a:prstGeom prst="rect">
@@ -13467,13 +13827,13 @@
       </p:sp>
       <p:sp>
         <p:nvSpPr>
-          <p:cNvPr id="26" name="TextBox 25"/>
-          <p:cNvSpPr txBox="1"/>
-          <p:nvPr/>
-        </p:nvSpPr>
-        <p:spPr>
-          <a:xfrm>
-            <a:off x="2286000" y="5806440"/>
+          <p:cNvPr id="36" name="TextBox 35"/>
+          <p:cNvSpPr txBox="1"/>
+          <p:nvPr/>
+        </p:nvSpPr>
+        <p:spPr>
+          <a:xfrm>
+            <a:off x="2286000" y="5715000"/>
             <a:ext cx="1371600" cy="274320"/>
           </a:xfrm>
           <a:prstGeom prst="rect">
@@ -13503,13 +13863,13 @@
       </p:sp>
       <p:sp>
         <p:nvSpPr>
-          <p:cNvPr id="27" name="TextBox 26"/>
-          <p:cNvSpPr txBox="1"/>
-          <p:nvPr/>
-        </p:nvSpPr>
-        <p:spPr>
-          <a:xfrm>
-            <a:off x="3657600" y="5806440"/>
+          <p:cNvPr id="37" name="TextBox 36"/>
+          <p:cNvSpPr txBox="1"/>
+          <p:nvPr/>
+        </p:nvSpPr>
+        <p:spPr>
+          <a:xfrm>
+            <a:off x="3657600" y="5715000"/>
             <a:ext cx="914400" cy="274320"/>
           </a:xfrm>
           <a:prstGeom prst="rect">
@@ -13539,13 +13899,13 @@
       </p:sp>
       <p:sp>
         <p:nvSpPr>
-          <p:cNvPr id="28" name="TextBox 27"/>
-          <p:cNvSpPr txBox="1"/>
-          <p:nvPr/>
-        </p:nvSpPr>
-        <p:spPr>
-          <a:xfrm>
-            <a:off x="914400" y="6126480"/>
+          <p:cNvPr id="38" name="TextBox 37"/>
+          <p:cNvSpPr txBox="1"/>
+          <p:nvPr/>
+        </p:nvSpPr>
+        <p:spPr>
+          <a:xfrm>
+            <a:off x="914400" y="6035040"/>
             <a:ext cx="1371600" cy="274320"/>
           </a:xfrm>
           <a:prstGeom prst="rect">
@@ -13575,13 +13935,13 @@
       </p:sp>
       <p:sp>
         <p:nvSpPr>
-          <p:cNvPr id="29" name="TextBox 28"/>
-          <p:cNvSpPr txBox="1"/>
-          <p:nvPr/>
-        </p:nvSpPr>
-        <p:spPr>
-          <a:xfrm>
-            <a:off x="2286000" y="6126480"/>
+          <p:cNvPr id="39" name="TextBox 38"/>
+          <p:cNvSpPr txBox="1"/>
+          <p:nvPr/>
+        </p:nvSpPr>
+        <p:spPr>
+          <a:xfrm>
+            <a:off x="2286000" y="6035040"/>
             <a:ext cx="1371600" cy="274320"/>
           </a:xfrm>
           <a:prstGeom prst="rect">
@@ -13611,13 +13971,13 @@
       </p:sp>
       <p:sp>
         <p:nvSpPr>
-          <p:cNvPr id="30" name="TextBox 29"/>
-          <p:cNvSpPr txBox="1"/>
-          <p:nvPr/>
-        </p:nvSpPr>
-        <p:spPr>
-          <a:xfrm>
-            <a:off x="3657600" y="6126480"/>
+          <p:cNvPr id="40" name="TextBox 39"/>
+          <p:cNvSpPr txBox="1"/>
+          <p:nvPr/>
+        </p:nvSpPr>
+        <p:spPr>
+          <a:xfrm>
+            <a:off x="3657600" y="6035040"/>
             <a:ext cx="914400" cy="274320"/>
           </a:xfrm>
           <a:prstGeom prst="rect">
@@ -13647,7 +14007,7 @@
       </p:sp>
       <p:sp>
         <p:nvSpPr>
-          <p:cNvPr id="31" name="TextBox 30"/>
+          <p:cNvPr id="41" name="TextBox 40"/>
           <p:cNvSpPr txBox="1"/>
           <p:nvPr/>
         </p:nvSpPr>
@@ -13683,7 +14043,7 @@
       </p:sp>
       <p:sp>
         <p:nvSpPr>
-          <p:cNvPr id="32" name="Rounded Rectangle 31"/>
+          <p:cNvPr id="42" name="Rounded Rectangle 41"/>
           <p:cNvSpPr/>
           <p:nvPr/>
         </p:nvSpPr>
@@ -13730,7 +14090,7 @@
       </p:sp>
       <p:sp>
         <p:nvSpPr>
-          <p:cNvPr id="33" name="TextBox 32"/>
+          <p:cNvPr id="43" name="TextBox 42"/>
           <p:cNvSpPr txBox="1"/>
           <p:nvPr/>
         </p:nvSpPr>
@@ -13766,7 +14126,7 @@
       </p:sp>
       <p:sp>
         <p:nvSpPr>
-          <p:cNvPr id="34" name="TextBox 33"/>
+          <p:cNvPr id="44" name="TextBox 43"/>
           <p:cNvSpPr txBox="1"/>
           <p:nvPr/>
         </p:nvSpPr>
@@ -13802,7 +14162,7 @@
       </p:sp>
       <p:sp>
         <p:nvSpPr>
-          <p:cNvPr id="35" name="TextBox 34"/>
+          <p:cNvPr id="45" name="TextBox 44"/>
           <p:cNvSpPr txBox="1"/>
           <p:nvPr/>
         </p:nvSpPr>
@@ -13838,7 +14198,7 @@
       </p:sp>
       <p:sp>
         <p:nvSpPr>
-          <p:cNvPr id="36" name="Rounded Rectangle 35"/>
+          <p:cNvPr id="46" name="Rounded Rectangle 45"/>
           <p:cNvSpPr/>
           <p:nvPr/>
         </p:nvSpPr>
@@ -13885,7 +14245,7 @@
       </p:sp>
       <p:sp>
         <p:nvSpPr>
-          <p:cNvPr id="37" name="TextBox 36"/>
+          <p:cNvPr id="47" name="TextBox 46"/>
           <p:cNvSpPr txBox="1"/>
           <p:nvPr/>
         </p:nvSpPr>
@@ -13921,7 +14281,7 @@
       </p:sp>
       <p:sp>
         <p:nvSpPr>
-          <p:cNvPr id="38" name="TextBox 37"/>
+          <p:cNvPr id="48" name="TextBox 47"/>
           <p:cNvSpPr txBox="1"/>
           <p:nvPr/>
         </p:nvSpPr>
@@ -13957,7 +14317,7 @@
       </p:sp>
       <p:sp>
         <p:nvSpPr>
-          <p:cNvPr id="39" name="TextBox 38"/>
+          <p:cNvPr id="49" name="TextBox 48"/>
           <p:cNvSpPr txBox="1"/>
           <p:nvPr/>
         </p:nvSpPr>
@@ -13993,7 +14353,7 @@
       </p:sp>
       <p:sp>
         <p:nvSpPr>
-          <p:cNvPr id="40" name="TextBox 39"/>
+          <p:cNvPr id="50" name="TextBox 49"/>
           <p:cNvSpPr txBox="1"/>
           <p:nvPr/>
         </p:nvSpPr>
@@ -14157,7 +14517,7 @@
       </p:sp>
       <p:sp>
         <p:nvSpPr>
-          <p:cNvPr id="41" name="Rounded Rectangle 40"/>
+          <p:cNvPr id="51" name="Rounded Rectangle 50"/>
           <p:cNvSpPr/>
           <p:nvPr/>
         </p:nvSpPr>
@@ -14204,7 +14564,7 @@
       </p:sp>
       <p:sp>
         <p:nvSpPr>
-          <p:cNvPr id="42" name="TextBox 41"/>
+          <p:cNvPr id="52" name="TextBox 51"/>
           <p:cNvSpPr txBox="1"/>
           <p:nvPr/>
         </p:nvSpPr>
@@ -14275,7 +14635,7 @@
       </p:sp>
       <p:sp>
         <p:nvSpPr>
-          <p:cNvPr id="43" name="TextBox 42"/>
+          <p:cNvPr id="53" name="TextBox 52"/>
           <p:cNvSpPr txBox="1"/>
           <p:nvPr/>
         </p:nvSpPr>
@@ -14311,7 +14671,7 @@
       </p:sp>
       <p:sp>
         <p:nvSpPr>
-          <p:cNvPr id="44" name="TextBox 43"/>
+          <p:cNvPr id="54" name="TextBox 53"/>
           <p:cNvSpPr txBox="1"/>
           <p:nvPr/>
         </p:nvSpPr>

</xml_diff>